<commit_message>
Fix RTL bidi ordering in the PowerPoint deck
Every mixed Hebrew/English sentence was reading out of order - the
presentation-level rtlMode flag doesn't propagate to individual
paragraphs in pptxgenjs; each text object needs its own rtl="1" on
<a:pPr>, which only rtlMode:true on that specific addText/table-cell
call produces. Added it to all 33 text boxes, every individual
rich-text run inside multi-run paragraphs, and every table cell.

Re-verified by rendering all 16 slides to images and reading each one
- every sentence with an embedded English term (Claude Code, RTL, AI,
PWA, Row Level Security, ROI, ANTHROPIC_API_KEY, model names, etc.)
now reads correctly right-to-left.

Co-Authored-By: Claude Sonnet 5 <noreply@anthropic.com>
</commit_message>
<xml_diff>
--- a/docs/presentation.pptx
+++ b/docs/presentation.pptx
@@ -2255,7 +2255,7 @@
           <a:bodyPr wrap="square" rtlCol="0" anchor="ctr"/>
           <a:lstStyle/>
           <a:p>
-            <a:pPr algn="ctr" indent="0" marL="0">
+            <a:pPr rtl="1" algn="ctr" indent="0" marL="0">
               <a:buNone/>
             </a:pPr>
             <a:r>
@@ -2269,7 +2269,7 @@
               </a:rPr>
               <a:t>Trip</a:t>
             </a:r>
-            <a:pPr algn="ctr" indent="0" marL="0">
+            <a:pPr rtl="1" algn="ctr" indent="0" marL="0">
               <a:buNone/>
             </a:pPr>
             <a:r>
@@ -2308,7 +2308,7 @@
           <a:bodyPr wrap="square" rtlCol="0" anchor="ctr"/>
           <a:lstStyle/>
           <a:p>
-            <a:pPr algn="ctr" indent="0" marL="0">
+            <a:pPr rtl="1" algn="ctr" indent="0" marL="0">
               <a:buNone/>
             </a:pPr>
             <a:r>
@@ -2347,7 +2347,7 @@
           <a:bodyPr wrap="square" rtlCol="0" anchor="ctr"/>
           <a:lstStyle/>
           <a:p>
-            <a:pPr algn="ctr" indent="0" marL="0">
+            <a:pPr rtl="1" algn="ctr" indent="0" marL="0">
               <a:buNone/>
             </a:pPr>
             <a:r>
@@ -2386,7 +2386,7 @@
           <a:bodyPr wrap="square" lIns="0" tIns="0" rIns="0" bIns="0" rtlCol="0" anchor="ctr"/>
           <a:lstStyle/>
           <a:p>
-            <a:pPr algn="ctr" indent="0" marL="0">
+            <a:pPr rtl="1" algn="ctr" indent="0" marL="0">
               <a:buNone/>
             </a:pPr>
             <a:r>
@@ -2425,7 +2425,7 @@
           <a:bodyPr wrap="square" lIns="0" tIns="0" rIns="0" bIns="0" rtlCol="0" anchor="ctr"/>
           <a:lstStyle/>
           <a:p>
-            <a:pPr algn="ctr" indent="0" marL="0">
+            <a:pPr rtl="1" algn="ctr" indent="0" marL="0">
               <a:buNone/>
             </a:pPr>
             <a:r>
@@ -2464,7 +2464,7 @@
           <a:bodyPr wrap="square" lIns="0" tIns="0" rIns="0" bIns="0" rtlCol="0" anchor="ctr"/>
           <a:lstStyle/>
           <a:p>
-            <a:pPr algn="ctr" indent="0" marL="0">
+            <a:pPr rtl="1" algn="ctr" indent="0" marL="0">
               <a:buNone/>
             </a:pPr>
             <a:r>
@@ -2503,7 +2503,7 @@
           <a:bodyPr wrap="square" lIns="0" tIns="0" rIns="0" bIns="0" rtlCol="0" anchor="ctr"/>
           <a:lstStyle/>
           <a:p>
-            <a:pPr algn="ctr" indent="0" marL="0">
+            <a:pPr rtl="1" algn="ctr" indent="0" marL="0">
               <a:buNone/>
             </a:pPr>
             <a:r>
@@ -2542,7 +2542,7 @@
           <a:bodyPr wrap="square" lIns="0" tIns="0" rIns="0" bIns="0" rtlCol="0" anchor="ctr"/>
           <a:lstStyle/>
           <a:p>
-            <a:pPr algn="ctr" indent="0" marL="0">
+            <a:pPr rtl="1" algn="ctr" indent="0" marL="0">
               <a:buNone/>
             </a:pPr>
             <a:r>
@@ -2581,7 +2581,7 @@
           <a:bodyPr wrap="square" lIns="0" tIns="0" rIns="0" bIns="0" rtlCol="0" anchor="ctr"/>
           <a:lstStyle/>
           <a:p>
-            <a:pPr algn="ctr" indent="0" marL="0">
+            <a:pPr rtl="1" algn="ctr" indent="0" marL="0">
               <a:buNone/>
             </a:pPr>
             <a:r>
@@ -2652,7 +2652,7 @@
           <a:bodyPr wrap="square" rtlCol="0" anchor="ctr"/>
           <a:lstStyle/>
           <a:p>
-            <a:pPr algn="r" indent="0" marL="0">
+            <a:pPr rtl="1" algn="r" indent="0" marL="0">
               <a:buNone/>
             </a:pPr>
             <a:r>
@@ -2691,7 +2691,7 @@
           <a:bodyPr wrap="square" rtlCol="0" anchor="t"/>
           <a:lstStyle/>
           <a:p>
-            <a:pPr algn="r" indent="0" marL="0">
+            <a:pPr rtl="1" algn="r" indent="0" marL="0">
               <a:buNone/>
             </a:pPr>
             <a:r>
@@ -2787,7 +2787,7 @@
           <a:bodyPr wrap="square" lIns="0" tIns="0" rIns="0" bIns="0" rtlCol="0" anchor="ctr"/>
           <a:lstStyle/>
           <a:p>
-            <a:pPr algn="r" indent="0" marL="0">
+            <a:pPr rtl="1" algn="r" indent="0" marL="0">
               <a:buNone/>
             </a:pPr>
             <a:r>
@@ -2826,7 +2826,7 @@
           <a:bodyPr wrap="square" lIns="0" tIns="0" rIns="0" bIns="0" rtlCol="0" anchor="t"/>
           <a:lstStyle/>
           <a:p>
-            <a:pPr algn="r" indent="0" marL="0">
+            <a:pPr rtl="1" algn="r" indent="0" marL="0">
               <a:buNone/>
             </a:pPr>
             <a:r>
@@ -2899,7 +2899,7 @@
           <a:bodyPr wrap="square" lIns="0" tIns="0" rIns="0" bIns="0" rtlCol="0" anchor="ctr"/>
           <a:lstStyle/>
           <a:p>
-            <a:pPr algn="r" indent="0" marL="0">
+            <a:pPr rtl="1" algn="r" indent="0" marL="0">
               <a:buNone/>
             </a:pPr>
             <a:r>
@@ -2938,7 +2938,7 @@
           <a:bodyPr wrap="square" lIns="0" tIns="0" rIns="0" bIns="0" rtlCol="0" anchor="t"/>
           <a:lstStyle/>
           <a:p>
-            <a:pPr algn="r" indent="0" marL="0">
+            <a:pPr rtl="1" algn="r" indent="0" marL="0">
               <a:buNone/>
             </a:pPr>
             <a:r>
@@ -2989,7 +2989,7 @@
                     <a:bodyPr/>
                     <a:lstStyle/>
                     <a:p>
-                      <a:pPr algn="r" indent="0" marL="0">
+                      <a:pPr rtl="1" algn="r" indent="0" marL="0">
                         <a:buNone/>
                       </a:pPr>
                       <a:r>
@@ -3057,7 +3057,7 @@
                     <a:bodyPr/>
                     <a:lstStyle/>
                     <a:p>
-                      <a:pPr algn="r" indent="0" marL="0">
+                      <a:pPr rtl="1" algn="r" indent="0" marL="0">
                         <a:buNone/>
                       </a:pPr>
                       <a:r>
@@ -3125,7 +3125,7 @@
                     <a:bodyPr/>
                     <a:lstStyle/>
                     <a:p>
-                      <a:pPr algn="r" indent="0" marL="0">
+                      <a:pPr rtl="1" algn="r" indent="0" marL="0">
                         <a:buNone/>
                       </a:pPr>
                       <a:r>
@@ -3195,7 +3195,7 @@
                     <a:bodyPr/>
                     <a:lstStyle/>
                     <a:p>
-                      <a:pPr algn="r" indent="0" marL="0">
+                      <a:pPr rtl="1" algn="r" indent="0" marL="0">
                         <a:buNone/>
                       </a:pPr>
                       <a:r>
@@ -3263,7 +3263,7 @@
                     <a:bodyPr/>
                     <a:lstStyle/>
                     <a:p>
-                      <a:pPr algn="r" indent="0" marL="0">
+                      <a:pPr rtl="1" algn="r" indent="0" marL="0">
                         <a:buNone/>
                       </a:pPr>
                       <a:r>
@@ -3331,7 +3331,7 @@
                     <a:bodyPr/>
                     <a:lstStyle/>
                     <a:p>
-                      <a:pPr algn="r" indent="0" marL="0">
+                      <a:pPr rtl="1" algn="r" indent="0" marL="0">
                         <a:buNone/>
                       </a:pPr>
                       <a:r>
@@ -3401,7 +3401,7 @@
                     <a:bodyPr/>
                     <a:lstStyle/>
                     <a:p>
-                      <a:pPr algn="r" indent="0" marL="0">
+                      <a:pPr rtl="1" algn="r" indent="0" marL="0">
                         <a:buNone/>
                       </a:pPr>
                       <a:r>
@@ -3469,7 +3469,7 @@
                     <a:bodyPr/>
                     <a:lstStyle/>
                     <a:p>
-                      <a:pPr algn="r" indent="0" marL="0">
+                      <a:pPr rtl="1" algn="r" indent="0" marL="0">
                         <a:buNone/>
                       </a:pPr>
                       <a:r>
@@ -3537,7 +3537,7 @@
                     <a:bodyPr/>
                     <a:lstStyle/>
                     <a:p>
-                      <a:pPr algn="r" indent="0" marL="0">
+                      <a:pPr rtl="1" algn="r" indent="0" marL="0">
                         <a:buNone/>
                       </a:pPr>
                       <a:r>
@@ -3607,7 +3607,7 @@
                     <a:bodyPr/>
                     <a:lstStyle/>
                     <a:p>
-                      <a:pPr algn="r" indent="0" marL="0">
+                      <a:pPr rtl="1" algn="r" indent="0" marL="0">
                         <a:buNone/>
                       </a:pPr>
                       <a:r>
@@ -3675,7 +3675,7 @@
                     <a:bodyPr/>
                     <a:lstStyle/>
                     <a:p>
-                      <a:pPr algn="r" indent="0" marL="0">
+                      <a:pPr rtl="1" algn="r" indent="0" marL="0">
                         <a:buNone/>
                       </a:pPr>
                       <a:r>
@@ -3743,7 +3743,7 @@
                     <a:bodyPr/>
                     <a:lstStyle/>
                     <a:p>
-                      <a:pPr algn="r" indent="0" marL="0">
+                      <a:pPr rtl="1" algn="r" indent="0" marL="0">
                         <a:buNone/>
                       </a:pPr>
                       <a:r>
@@ -3813,7 +3813,7 @@
                     <a:bodyPr/>
                     <a:lstStyle/>
                     <a:p>
-                      <a:pPr algn="r" indent="0" marL="0">
+                      <a:pPr rtl="1" algn="r" indent="0" marL="0">
                         <a:buNone/>
                       </a:pPr>
                       <a:r>
@@ -3881,7 +3881,7 @@
                     <a:bodyPr/>
                     <a:lstStyle/>
                     <a:p>
-                      <a:pPr algn="r" indent="0" marL="0">
+                      <a:pPr rtl="1" algn="r" indent="0" marL="0">
                         <a:buNone/>
                       </a:pPr>
                       <a:r>
@@ -3949,7 +3949,7 @@
                     <a:bodyPr/>
                     <a:lstStyle/>
                     <a:p>
-                      <a:pPr algn="r" indent="0" marL="0">
+                      <a:pPr rtl="1" algn="r" indent="0" marL="0">
                         <a:buNone/>
                       </a:pPr>
                       <a:r>
@@ -4019,7 +4019,7 @@
                     <a:bodyPr/>
                     <a:lstStyle/>
                     <a:p>
-                      <a:pPr algn="r" indent="0" marL="0">
+                      <a:pPr rtl="1" algn="r" indent="0" marL="0">
                         <a:buNone/>
                       </a:pPr>
                       <a:r>
@@ -4087,7 +4087,7 @@
                     <a:bodyPr/>
                     <a:lstStyle/>
                     <a:p>
-                      <a:pPr algn="r" indent="0" marL="0">
+                      <a:pPr rtl="1" algn="r" indent="0" marL="0">
                         <a:buNone/>
                       </a:pPr>
                       <a:r>
@@ -4155,7 +4155,7 @@
                     <a:bodyPr/>
                     <a:lstStyle/>
                     <a:p>
-                      <a:pPr algn="r" indent="0" marL="0">
+                      <a:pPr rtl="1" algn="r" indent="0" marL="0">
                         <a:buNone/>
                       </a:pPr>
                       <a:r>
@@ -4244,7 +4244,7 @@
           <a:bodyPr wrap="square" rtlCol="0" anchor="ctr"/>
           <a:lstStyle/>
           <a:p>
-            <a:pPr algn="l" indent="0" marL="0">
+            <a:pPr rtl="1" algn="l" indent="0" marL="0">
               <a:buNone/>
             </a:pPr>
             <a:r>
@@ -4315,7 +4315,7 @@
           <a:bodyPr wrap="square" rtlCol="0" anchor="ctr"/>
           <a:lstStyle/>
           <a:p>
-            <a:pPr algn="r" indent="0" marL="0">
+            <a:pPr rtl="1" algn="r" indent="0" marL="0">
               <a:buNone/>
             </a:pPr>
             <a:r>
@@ -4354,7 +4354,7 @@
           <a:bodyPr wrap="square" rtlCol="0" anchor="t"/>
           <a:lstStyle/>
           <a:p>
-            <a:pPr algn="r" indent="0" marL="0">
+            <a:pPr rtl="1" algn="r" indent="0" marL="0">
               <a:buNone/>
             </a:pPr>
             <a:r>
@@ -4393,7 +4393,7 @@
           <a:bodyPr wrap="square" rtlCol="0" anchor="t"/>
           <a:lstStyle/>
           <a:p>
-            <a:pPr algn="r" indent="0" marL="0">
+            <a:pPr rtl="1" algn="r" indent="0" marL="0">
               <a:buNone/>
             </a:pPr>
             <a:r>
@@ -4513,7 +4513,7 @@
           <a:bodyPr wrap="square" lIns="0" tIns="0" rIns="0" bIns="0" rtlCol="0" anchor="t"/>
           <a:lstStyle/>
           <a:p>
-            <a:pPr algn="ctr" indent="0" marL="0">
+            <a:pPr rtl="1" algn="ctr" indent="0" marL="0">
               <a:lnSpc>
                 <a:spcPct val="115000"/>
               </a:lnSpc>
@@ -4533,7 +4533,7 @@
             <a:endParaRPr lang="en-US" sz="1200" dirty="0"/>
           </a:p>
           <a:p>
-            <a:pPr algn="ctr" indent="0" marL="0">
+            <a:pPr rtl="1" algn="ctr" indent="0" marL="0">
               <a:lnSpc>
                 <a:spcPct val="115000"/>
               </a:lnSpc>
@@ -4633,7 +4633,7 @@
           <a:bodyPr wrap="square" lIns="0" tIns="0" rIns="0" bIns="0" rtlCol="0" anchor="t"/>
           <a:lstStyle/>
           <a:p>
-            <a:pPr algn="ctr" indent="0" marL="0">
+            <a:pPr rtl="1" algn="ctr" indent="0" marL="0">
               <a:lnSpc>
                 <a:spcPct val="115000"/>
               </a:lnSpc>
@@ -4653,7 +4653,7 @@
             <a:endParaRPr lang="en-US" sz="1200" dirty="0"/>
           </a:p>
           <a:p>
-            <a:pPr algn="ctr" indent="0" marL="0">
+            <a:pPr rtl="1" algn="ctr" indent="0" marL="0">
               <a:lnSpc>
                 <a:spcPct val="115000"/>
               </a:lnSpc>
@@ -4753,7 +4753,7 @@
           <a:bodyPr wrap="square" lIns="0" tIns="0" rIns="0" bIns="0" rtlCol="0" anchor="t"/>
           <a:lstStyle/>
           <a:p>
-            <a:pPr algn="ctr" indent="0" marL="0">
+            <a:pPr rtl="1" algn="ctr" indent="0" marL="0">
               <a:lnSpc>
                 <a:spcPct val="115000"/>
               </a:lnSpc>
@@ -4773,7 +4773,7 @@
             <a:endParaRPr lang="en-US" sz="1200" dirty="0"/>
           </a:p>
           <a:p>
-            <a:pPr algn="ctr" indent="0" marL="0">
+            <a:pPr rtl="1" algn="ctr" indent="0" marL="0">
               <a:lnSpc>
                 <a:spcPct val="115000"/>
               </a:lnSpc>
@@ -4815,7 +4815,7 @@
           <a:bodyPr wrap="square" rtlCol="0" anchor="ctr"/>
           <a:lstStyle/>
           <a:p>
-            <a:pPr algn="l" indent="0" marL="0">
+            <a:pPr rtl="1" algn="l" indent="0" marL="0">
               <a:buNone/>
             </a:pPr>
             <a:r>
@@ -4886,7 +4886,7 @@
           <a:bodyPr wrap="square" rtlCol="0" anchor="ctr"/>
           <a:lstStyle/>
           <a:p>
-            <a:pPr algn="r" indent="0" marL="0">
+            <a:pPr rtl="1" algn="r" indent="0" marL="0">
               <a:buNone/>
             </a:pPr>
             <a:r>
@@ -4925,7 +4925,7 @@
           <a:bodyPr wrap="square" rtlCol="0" anchor="t"/>
           <a:lstStyle/>
           <a:p>
-            <a:pPr algn="r" indent="0" marL="0">
+            <a:pPr rtl="1" algn="r" indent="0" marL="0">
               <a:buNone/>
             </a:pPr>
             <a:r>
@@ -4964,7 +4964,7 @@
           <a:bodyPr wrap="square" rtlCol="0" anchor="t"/>
           <a:lstStyle/>
           <a:p>
-            <a:pPr algn="r" indent="0" marL="0">
+            <a:pPr rtl="1" algn="r" indent="0" marL="0">
               <a:buNone/>
             </a:pPr>
             <a:r>
@@ -5084,7 +5084,7 @@
           <a:bodyPr wrap="square" lIns="0" tIns="0" rIns="0" bIns="0" rtlCol="0" anchor="t"/>
           <a:lstStyle/>
           <a:p>
-            <a:pPr algn="ctr" indent="0" marL="0">
+            <a:pPr rtl="1" algn="ctr" indent="0" marL="0">
               <a:lnSpc>
                 <a:spcPct val="115000"/>
               </a:lnSpc>
@@ -5104,7 +5104,7 @@
             <a:endParaRPr lang="en-US" sz="1200" dirty="0"/>
           </a:p>
           <a:p>
-            <a:pPr algn="ctr" indent="0" marL="0">
+            <a:pPr rtl="1" algn="ctr" indent="0" marL="0">
               <a:lnSpc>
                 <a:spcPct val="115000"/>
               </a:lnSpc>
@@ -5204,7 +5204,7 @@
           <a:bodyPr wrap="square" lIns="0" tIns="0" rIns="0" bIns="0" rtlCol="0" anchor="t"/>
           <a:lstStyle/>
           <a:p>
-            <a:pPr algn="ctr" indent="0" marL="0">
+            <a:pPr rtl="1" algn="ctr" indent="0" marL="0">
               <a:lnSpc>
                 <a:spcPct val="115000"/>
               </a:lnSpc>
@@ -5224,7 +5224,7 @@
             <a:endParaRPr lang="en-US" sz="1200" dirty="0"/>
           </a:p>
           <a:p>
-            <a:pPr algn="ctr" indent="0" marL="0">
+            <a:pPr rtl="1" algn="ctr" indent="0" marL="0">
               <a:lnSpc>
                 <a:spcPct val="115000"/>
               </a:lnSpc>
@@ -5266,7 +5266,7 @@
           <a:bodyPr wrap="square" rtlCol="0" anchor="ctr"/>
           <a:lstStyle/>
           <a:p>
-            <a:pPr algn="l" indent="0" marL="0">
+            <a:pPr rtl="1" algn="l" indent="0" marL="0">
               <a:buNone/>
             </a:pPr>
             <a:r>
@@ -5337,7 +5337,7 @@
           <a:bodyPr wrap="square" rtlCol="0" anchor="ctr"/>
           <a:lstStyle/>
           <a:p>
-            <a:pPr algn="r" indent="0" marL="0">
+            <a:pPr rtl="1" algn="r" indent="0" marL="0">
               <a:buNone/>
             </a:pPr>
             <a:r>
@@ -5376,7 +5376,7 @@
           <a:bodyPr wrap="square" rtlCol="0" anchor="t"/>
           <a:lstStyle/>
           <a:p>
-            <a:pPr algn="r" indent="0" marL="0">
+            <a:pPr rtl="1" algn="r" indent="0" marL="0">
               <a:buNone/>
             </a:pPr>
             <a:r>
@@ -5415,7 +5415,7 @@
           <a:bodyPr wrap="square" rtlCol="0" anchor="t"/>
           <a:lstStyle/>
           <a:p>
-            <a:pPr algn="r" indent="0" marL="0">
+            <a:pPr rtl="1" algn="r" indent="0" marL="0">
               <a:buNone/>
             </a:pPr>
             <a:r>
@@ -5535,7 +5535,7 @@
           <a:bodyPr wrap="square" lIns="0" tIns="0" rIns="0" bIns="0" rtlCol="0" anchor="t"/>
           <a:lstStyle/>
           <a:p>
-            <a:pPr algn="ctr" indent="0" marL="0">
+            <a:pPr rtl="1" algn="ctr" indent="0" marL="0">
               <a:lnSpc>
                 <a:spcPct val="115000"/>
               </a:lnSpc>
@@ -5555,7 +5555,7 @@
             <a:endParaRPr lang="en-US" sz="1200" dirty="0"/>
           </a:p>
           <a:p>
-            <a:pPr algn="ctr" indent="0" marL="0">
+            <a:pPr rtl="1" algn="ctr" indent="0" marL="0">
               <a:lnSpc>
                 <a:spcPct val="115000"/>
               </a:lnSpc>
@@ -5655,7 +5655,7 @@
           <a:bodyPr wrap="square" lIns="0" tIns="0" rIns="0" bIns="0" rtlCol="0" anchor="t"/>
           <a:lstStyle/>
           <a:p>
-            <a:pPr algn="ctr" indent="0" marL="0">
+            <a:pPr rtl="1" algn="ctr" indent="0" marL="0">
               <a:lnSpc>
                 <a:spcPct val="115000"/>
               </a:lnSpc>
@@ -5675,7 +5675,7 @@
             <a:endParaRPr lang="en-US" sz="1200" dirty="0"/>
           </a:p>
           <a:p>
-            <a:pPr algn="ctr" indent="0" marL="0">
+            <a:pPr rtl="1" algn="ctr" indent="0" marL="0">
               <a:lnSpc>
                 <a:spcPct val="115000"/>
               </a:lnSpc>
@@ -5717,7 +5717,7 @@
           <a:bodyPr wrap="square" rtlCol="0" anchor="ctr"/>
           <a:lstStyle/>
           <a:p>
-            <a:pPr algn="l" indent="0" marL="0">
+            <a:pPr rtl="1" algn="l" indent="0" marL="0">
               <a:buNone/>
             </a:pPr>
             <a:r>
@@ -5788,7 +5788,7 @@
           <a:bodyPr wrap="square" rtlCol="0" anchor="ctr"/>
           <a:lstStyle/>
           <a:p>
-            <a:pPr algn="r" indent="0" marL="0">
+            <a:pPr rtl="1" algn="r" indent="0" marL="0">
               <a:buNone/>
             </a:pPr>
             <a:r>
@@ -5827,7 +5827,7 @@
           <a:bodyPr wrap="square" rtlCol="0" anchor="t"/>
           <a:lstStyle/>
           <a:p>
-            <a:pPr algn="r" indent="0" marL="0">
+            <a:pPr rtl="1" algn="r" indent="0" marL="0">
               <a:buNone/>
             </a:pPr>
             <a:r>
@@ -5866,7 +5866,7 @@
           <a:bodyPr wrap="square" rtlCol="0" anchor="t"/>
           <a:lstStyle/>
           <a:p>
-            <a:pPr algn="r" indent="0" marL="0">
+            <a:pPr rtl="1" algn="r" indent="0" marL="0">
               <a:buNone/>
             </a:pPr>
             <a:r>
@@ -5962,7 +5962,7 @@
           <a:bodyPr wrap="square" lIns="0" tIns="0" rIns="0" bIns="0" rtlCol="0" anchor="ctr"/>
           <a:lstStyle/>
           <a:p>
-            <a:pPr algn="r" indent="0" marL="0">
+            <a:pPr rtl="1" algn="r" indent="0" marL="0">
               <a:buNone/>
             </a:pPr>
             <a:r>
@@ -6001,7 +6001,7 @@
           <a:bodyPr wrap="square" lIns="0" tIns="0" rIns="0" bIns="0" rtlCol="0" anchor="t"/>
           <a:lstStyle/>
           <a:p>
-            <a:pPr algn="r" indent="0" marL="0">
+            <a:pPr rtl="1" algn="r" indent="0" marL="0">
               <a:buNone/>
             </a:pPr>
             <a:r>
@@ -6074,7 +6074,7 @@
           <a:bodyPr wrap="square" lIns="0" tIns="0" rIns="0" bIns="0" rtlCol="0" anchor="ctr"/>
           <a:lstStyle/>
           <a:p>
-            <a:pPr algn="r" indent="0" marL="0">
+            <a:pPr rtl="1" algn="r" indent="0" marL="0">
               <a:buNone/>
             </a:pPr>
             <a:r>
@@ -6113,7 +6113,7 @@
           <a:bodyPr wrap="square" lIns="0" tIns="0" rIns="0" bIns="0" rtlCol="0" anchor="t"/>
           <a:lstStyle/>
           <a:p>
-            <a:pPr algn="r" indent="0" marL="0">
+            <a:pPr rtl="1" algn="r" indent="0" marL="0">
               <a:buNone/>
             </a:pPr>
             <a:r>
@@ -6186,7 +6186,7 @@
           <a:bodyPr wrap="square" lIns="0" tIns="0" rIns="0" bIns="0" rtlCol="0" anchor="ctr"/>
           <a:lstStyle/>
           <a:p>
-            <a:pPr algn="r" indent="0" marL="0">
+            <a:pPr rtl="1" algn="r" indent="0" marL="0">
               <a:buNone/>
             </a:pPr>
             <a:r>
@@ -6225,7 +6225,7 @@
           <a:bodyPr wrap="square" lIns="0" tIns="0" rIns="0" bIns="0" rtlCol="0" anchor="t"/>
           <a:lstStyle/>
           <a:p>
-            <a:pPr algn="r" indent="0" marL="0">
+            <a:pPr rtl="1" algn="r" indent="0" marL="0">
               <a:buNone/>
             </a:pPr>
             <a:r>
@@ -6298,7 +6298,7 @@
           <a:bodyPr wrap="square" lIns="0" tIns="0" rIns="0" bIns="0" rtlCol="0" anchor="t"/>
           <a:lstStyle/>
           <a:p>
-            <a:pPr algn="r" indent="0" marL="0">
+            <a:pPr rtl="1" algn="r" indent="0" marL="0">
               <a:buNone/>
             </a:pPr>
             <a:r>
@@ -6337,7 +6337,7 @@
           <a:bodyPr wrap="square" rtlCol="0" anchor="ctr"/>
           <a:lstStyle/>
           <a:p>
-            <a:pPr algn="l" indent="0" marL="0">
+            <a:pPr rtl="1" algn="l" indent="0" marL="0">
               <a:buNone/>
             </a:pPr>
             <a:r>
@@ -6408,7 +6408,7 @@
           <a:bodyPr wrap="square" rtlCol="0" anchor="ctr"/>
           <a:lstStyle/>
           <a:p>
-            <a:pPr algn="r" indent="0" marL="0">
+            <a:pPr rtl="1" algn="r" indent="0" marL="0">
               <a:buNone/>
             </a:pPr>
             <a:r>
@@ -6447,7 +6447,7 @@
           <a:bodyPr wrap="square" rtlCol="0" anchor="t"/>
           <a:lstStyle/>
           <a:p>
-            <a:pPr algn="r" indent="0" marL="0">
+            <a:pPr rtl="1" algn="r" indent="0" marL="0">
               <a:buNone/>
             </a:pPr>
             <a:r>
@@ -6543,7 +6543,7 @@
           <a:bodyPr wrap="square" lIns="0" tIns="0" rIns="0" bIns="0" rtlCol="0" anchor="ctr"/>
           <a:lstStyle/>
           <a:p>
-            <a:pPr algn="ctr" indent="0" marL="0">
+            <a:pPr rtl="1" algn="ctr" indent="0" marL="0">
               <a:buNone/>
             </a:pPr>
             <a:r>
@@ -6582,7 +6582,7 @@
           <a:bodyPr wrap="square" lIns="0" tIns="0" rIns="0" bIns="0" rtlCol="0" anchor="ctr"/>
           <a:lstStyle/>
           <a:p>
-            <a:pPr algn="ctr" indent="0" marL="0">
+            <a:pPr rtl="1" algn="ctr" indent="0" marL="0">
               <a:buNone/>
             </a:pPr>
             <a:r>
@@ -6621,7 +6621,7 @@
           <a:bodyPr wrap="square" lIns="0" tIns="0" rIns="0" bIns="0" rtlCol="0" anchor="t"/>
           <a:lstStyle/>
           <a:p>
-            <a:pPr algn="ctr" indent="0" marL="0">
+            <a:pPr rtl="1" algn="ctr" indent="0" marL="0">
               <a:buNone/>
             </a:pPr>
             <a:r>
@@ -6694,7 +6694,7 @@
           <a:bodyPr wrap="square" lIns="0" tIns="0" rIns="0" bIns="0" rtlCol="0" anchor="ctr"/>
           <a:lstStyle/>
           <a:p>
-            <a:pPr algn="ctr" indent="0" marL="0">
+            <a:pPr rtl="1" algn="ctr" indent="0" marL="0">
               <a:buNone/>
             </a:pPr>
             <a:r>
@@ -6733,7 +6733,7 @@
           <a:bodyPr wrap="square" lIns="0" tIns="0" rIns="0" bIns="0" rtlCol="0" anchor="ctr"/>
           <a:lstStyle/>
           <a:p>
-            <a:pPr algn="ctr" indent="0" marL="0">
+            <a:pPr rtl="1" algn="ctr" indent="0" marL="0">
               <a:buNone/>
             </a:pPr>
             <a:r>
@@ -6772,7 +6772,7 @@
           <a:bodyPr wrap="square" lIns="0" tIns="0" rIns="0" bIns="0" rtlCol="0" anchor="t"/>
           <a:lstStyle/>
           <a:p>
-            <a:pPr algn="ctr" indent="0" marL="0">
+            <a:pPr rtl="1" algn="ctr" indent="0" marL="0">
               <a:buNone/>
             </a:pPr>
             <a:r>
@@ -6845,7 +6845,7 @@
           <a:bodyPr wrap="square" lIns="0" tIns="0" rIns="0" bIns="0" rtlCol="0" anchor="ctr"/>
           <a:lstStyle/>
           <a:p>
-            <a:pPr algn="ctr" indent="0" marL="0">
+            <a:pPr rtl="1" algn="ctr" indent="0" marL="0">
               <a:buNone/>
             </a:pPr>
             <a:r>
@@ -6884,7 +6884,7 @@
           <a:bodyPr wrap="square" lIns="0" tIns="0" rIns="0" bIns="0" rtlCol="0" anchor="ctr"/>
           <a:lstStyle/>
           <a:p>
-            <a:pPr algn="ctr" indent="0" marL="0">
+            <a:pPr rtl="1" algn="ctr" indent="0" marL="0">
               <a:buNone/>
             </a:pPr>
             <a:r>
@@ -6923,7 +6923,7 @@
           <a:bodyPr wrap="square" lIns="0" tIns="0" rIns="0" bIns="0" rtlCol="0" anchor="t"/>
           <a:lstStyle/>
           <a:p>
-            <a:pPr algn="ctr" indent="0" marL="0">
+            <a:pPr rtl="1" algn="ctr" indent="0" marL="0">
               <a:buNone/>
             </a:pPr>
             <a:r>
@@ -6996,7 +6996,7 @@
           <a:bodyPr wrap="square" lIns="0" tIns="0" rIns="0" bIns="0" rtlCol="0" anchor="ctr"/>
           <a:lstStyle/>
           <a:p>
-            <a:pPr algn="ctr" indent="0" marL="0">
+            <a:pPr rtl="1" algn="ctr" indent="0" marL="0">
               <a:buNone/>
             </a:pPr>
             <a:r>
@@ -7035,7 +7035,7 @@
           <a:bodyPr wrap="square" lIns="0" tIns="0" rIns="0" bIns="0" rtlCol="0" anchor="ctr"/>
           <a:lstStyle/>
           <a:p>
-            <a:pPr algn="ctr" indent="0" marL="0">
+            <a:pPr rtl="1" algn="ctr" indent="0" marL="0">
               <a:buNone/>
             </a:pPr>
             <a:r>
@@ -7074,7 +7074,7 @@
           <a:bodyPr wrap="square" lIns="0" tIns="0" rIns="0" bIns="0" rtlCol="0" anchor="t"/>
           <a:lstStyle/>
           <a:p>
-            <a:pPr algn="ctr" indent="0" marL="0">
+            <a:pPr rtl="1" algn="ctr" indent="0" marL="0">
               <a:buNone/>
             </a:pPr>
             <a:r>
@@ -7147,7 +7147,7 @@
           <a:bodyPr wrap="square" lIns="0" tIns="0" rIns="0" bIns="0" rtlCol="0" anchor="ctr"/>
           <a:lstStyle/>
           <a:p>
-            <a:pPr algn="ctr" indent="0" marL="0">
+            <a:pPr rtl="1" algn="ctr" indent="0" marL="0">
               <a:buNone/>
             </a:pPr>
             <a:r>
@@ -7186,7 +7186,7 @@
           <a:bodyPr wrap="square" lIns="0" tIns="0" rIns="0" bIns="0" rtlCol="0" anchor="ctr"/>
           <a:lstStyle/>
           <a:p>
-            <a:pPr algn="ctr" indent="0" marL="0">
+            <a:pPr rtl="1" algn="ctr" indent="0" marL="0">
               <a:buNone/>
             </a:pPr>
             <a:r>
@@ -7225,7 +7225,7 @@
           <a:bodyPr wrap="square" lIns="0" tIns="0" rIns="0" bIns="0" rtlCol="0" anchor="t"/>
           <a:lstStyle/>
           <a:p>
-            <a:pPr algn="ctr" indent="0" marL="0">
+            <a:pPr rtl="1" algn="ctr" indent="0" marL="0">
               <a:buNone/>
             </a:pPr>
             <a:r>
@@ -7298,7 +7298,7 @@
           <a:bodyPr wrap="square" lIns="0" tIns="0" rIns="0" bIns="0" rtlCol="0" anchor="ctr"/>
           <a:lstStyle/>
           <a:p>
-            <a:pPr algn="ctr" indent="0" marL="0">
+            <a:pPr rtl="1" algn="ctr" indent="0" marL="0">
               <a:buNone/>
             </a:pPr>
             <a:r>
@@ -7337,7 +7337,7 @@
           <a:bodyPr wrap="square" lIns="0" tIns="0" rIns="0" bIns="0" rtlCol="0" anchor="ctr"/>
           <a:lstStyle/>
           <a:p>
-            <a:pPr algn="ctr" indent="0" marL="0">
+            <a:pPr rtl="1" algn="ctr" indent="0" marL="0">
               <a:buNone/>
             </a:pPr>
             <a:r>
@@ -7376,7 +7376,7 @@
           <a:bodyPr wrap="square" lIns="0" tIns="0" rIns="0" bIns="0" rtlCol="0" anchor="t"/>
           <a:lstStyle/>
           <a:p>
-            <a:pPr algn="ctr" indent="0" marL="0">
+            <a:pPr rtl="1" algn="ctr" indent="0" marL="0">
               <a:buNone/>
             </a:pPr>
             <a:r>
@@ -7415,7 +7415,7 @@
           <a:bodyPr wrap="square" rtlCol="0" anchor="ctr"/>
           <a:lstStyle/>
           <a:p>
-            <a:pPr algn="l" indent="0" marL="0">
+            <a:pPr rtl="1" algn="l" indent="0" marL="0">
               <a:buNone/>
             </a:pPr>
             <a:r>
@@ -7486,7 +7486,7 @@
           <a:bodyPr wrap="square" rtlCol="0" anchor="ctr"/>
           <a:lstStyle/>
           <a:p>
-            <a:pPr algn="r" indent="0" marL="0">
+            <a:pPr rtl="1" algn="r" indent="0" marL="0">
               <a:buNone/>
             </a:pPr>
             <a:r>
@@ -7525,7 +7525,7 @@
           <a:bodyPr wrap="square" rtlCol="0" anchor="t"/>
           <a:lstStyle/>
           <a:p>
-            <a:pPr algn="r" indent="0" marL="0">
+            <a:pPr rtl="1" algn="r" indent="0" marL="0">
               <a:buNone/>
             </a:pPr>
             <a:r>
@@ -7621,7 +7621,7 @@
           <a:bodyPr wrap="square" lIns="0" tIns="0" rIns="0" bIns="0" rtlCol="0" anchor="ctr"/>
           <a:lstStyle/>
           <a:p>
-            <a:pPr algn="r" indent="0" marL="0">
+            <a:pPr rtl="1" algn="r" indent="0" marL="0">
               <a:buNone/>
             </a:pPr>
             <a:r>
@@ -7660,7 +7660,7 @@
           <a:bodyPr wrap="square" lIns="0" tIns="0" rIns="0" bIns="0" rtlCol="0" anchor="t"/>
           <a:lstStyle/>
           <a:p>
-            <a:pPr algn="r" indent="0" marL="0">
+            <a:pPr rtl="1" algn="r" indent="0" marL="0">
               <a:buNone/>
             </a:pPr>
             <a:r>
@@ -7733,7 +7733,7 @@
           <a:bodyPr wrap="square" lIns="0" tIns="0" rIns="0" bIns="0" rtlCol="0" anchor="ctr"/>
           <a:lstStyle/>
           <a:p>
-            <a:pPr algn="r" indent="0" marL="0">
+            <a:pPr rtl="1" algn="r" indent="0" marL="0">
               <a:buNone/>
             </a:pPr>
             <a:r>
@@ -7772,7 +7772,7 @@
           <a:bodyPr wrap="square" lIns="0" tIns="0" rIns="0" bIns="0" rtlCol="0" anchor="t"/>
           <a:lstStyle/>
           <a:p>
-            <a:pPr algn="r" indent="0" marL="0">
+            <a:pPr rtl="1" algn="r" indent="0" marL="0">
               <a:buNone/>
             </a:pPr>
             <a:r>
@@ -7811,7 +7811,7 @@
           <a:bodyPr wrap="square" rtlCol="0" anchor="ctr"/>
           <a:lstStyle/>
           <a:p>
-            <a:pPr algn="ctr" indent="0" marL="0">
+            <a:pPr rtl="1" algn="ctr" indent="0" marL="0">
               <a:buNone/>
             </a:pPr>
             <a:r>
@@ -7825,7 +7825,7 @@
               </a:rPr>
               <a:t>TripCraft · </a:t>
             </a:r>
-            <a:pPr algn="ctr" indent="0" marL="0">
+            <a:pPr rtl="1" algn="ctr" indent="0" marL="0">
               <a:buNone/>
             </a:pPr>
             <a:r>
@@ -7839,7 +7839,7 @@
               </a:rPr>
               <a:t>מלווה הטיולים שלך</a:t>
             </a:r>
-            <a:pPr algn="ctr" indent="0" marL="0">
+            <a:pPr rtl="1" algn="ctr" indent="0" marL="0">
               <a:buNone/>
             </a:pPr>
             <a:r>
@@ -7910,7 +7910,7 @@
           <a:bodyPr wrap="square" rtlCol="0" anchor="ctr"/>
           <a:lstStyle/>
           <a:p>
-            <a:pPr algn="r" indent="0" marL="0">
+            <a:pPr rtl="1" algn="r" indent="0" marL="0">
               <a:buNone/>
             </a:pPr>
             <a:r>
@@ -7949,7 +7949,7 @@
           <a:bodyPr wrap="square" rtlCol="0" anchor="t"/>
           <a:lstStyle/>
           <a:p>
-            <a:pPr algn="r" indent="0" marL="0">
+            <a:pPr rtl="1" algn="r" indent="0" marL="0">
               <a:buNone/>
             </a:pPr>
             <a:r>
@@ -7988,7 +7988,7 @@
           <a:bodyPr wrap="square" rtlCol="0" anchor="t"/>
           <a:lstStyle/>
           <a:p>
-            <a:pPr algn="r" indent="0" marL="0">
+            <a:pPr rtl="1" algn="r" indent="0" marL="0">
               <a:buNone/>
             </a:pPr>
             <a:r>
@@ -8084,7 +8084,7 @@
           <a:bodyPr wrap="square" lIns="0" tIns="0" rIns="0" bIns="0" rtlCol="0" anchor="ctr"/>
           <a:lstStyle/>
           <a:p>
-            <a:pPr algn="r" indent="0" marL="0">
+            <a:pPr rtl="1" algn="r" indent="0" marL="0">
               <a:buNone/>
             </a:pPr>
             <a:r>
@@ -8123,7 +8123,7 @@
           <a:bodyPr wrap="square" lIns="0" tIns="0" rIns="0" bIns="0" rtlCol="0" anchor="t"/>
           <a:lstStyle/>
           <a:p>
-            <a:pPr algn="r" indent="0" marL="0">
+            <a:pPr rtl="1" algn="r" indent="0" marL="0">
               <a:buNone/>
             </a:pPr>
             <a:r>
@@ -8196,7 +8196,7 @@
           <a:bodyPr wrap="square" lIns="0" tIns="0" rIns="0" bIns="0" rtlCol="0" anchor="ctr"/>
           <a:lstStyle/>
           <a:p>
-            <a:pPr algn="r" indent="0" marL="0">
+            <a:pPr rtl="1" algn="r" indent="0" marL="0">
               <a:buNone/>
             </a:pPr>
             <a:r>
@@ -8235,7 +8235,7 @@
           <a:bodyPr wrap="square" lIns="0" tIns="0" rIns="0" bIns="0" rtlCol="0" anchor="t"/>
           <a:lstStyle/>
           <a:p>
-            <a:pPr algn="r" indent="0" marL="0">
+            <a:pPr rtl="1" algn="r" indent="0" marL="0">
               <a:buNone/>
             </a:pPr>
             <a:r>
@@ -8308,7 +8308,7 @@
           <a:bodyPr wrap="square" lIns="0" tIns="0" rIns="0" bIns="0" rtlCol="0" anchor="ctr"/>
           <a:lstStyle/>
           <a:p>
-            <a:pPr algn="r" indent="0" marL="0">
+            <a:pPr rtl="1" algn="r" indent="0" marL="0">
               <a:buNone/>
             </a:pPr>
             <a:r>
@@ -8347,7 +8347,7 @@
           <a:bodyPr wrap="square" lIns="0" tIns="0" rIns="0" bIns="0" rtlCol="0" anchor="t"/>
           <a:lstStyle/>
           <a:p>
-            <a:pPr algn="r" indent="0" marL="0">
+            <a:pPr rtl="1" algn="r" indent="0" marL="0">
               <a:buNone/>
             </a:pPr>
             <a:r>
@@ -8420,7 +8420,7 @@
           <a:bodyPr wrap="square" lIns="0" tIns="0" rIns="0" bIns="0" rtlCol="0" anchor="ctr"/>
           <a:lstStyle/>
           <a:p>
-            <a:pPr algn="r" indent="0" marL="0">
+            <a:pPr rtl="1" algn="r" indent="0" marL="0">
               <a:buNone/>
             </a:pPr>
             <a:r>
@@ -8459,7 +8459,7 @@
           <a:bodyPr wrap="square" lIns="0" tIns="0" rIns="0" bIns="0" rtlCol="0" anchor="t"/>
           <a:lstStyle/>
           <a:p>
-            <a:pPr algn="r" indent="0" marL="0">
+            <a:pPr rtl="1" algn="r" indent="0" marL="0">
               <a:buNone/>
             </a:pPr>
             <a:r>
@@ -8532,7 +8532,7 @@
           <a:bodyPr wrap="square" lIns="0" tIns="0" rIns="0" bIns="0" rtlCol="0" anchor="ctr"/>
           <a:lstStyle/>
           <a:p>
-            <a:pPr algn="r" indent="0" marL="0">
+            <a:pPr rtl="1" algn="r" indent="0" marL="0">
               <a:buNone/>
             </a:pPr>
             <a:r>
@@ -8571,7 +8571,7 @@
           <a:bodyPr wrap="square" lIns="0" tIns="0" rIns="0" bIns="0" rtlCol="0" anchor="t"/>
           <a:lstStyle/>
           <a:p>
-            <a:pPr algn="r" indent="0" marL="0">
+            <a:pPr rtl="1" algn="r" indent="0" marL="0">
               <a:buNone/>
             </a:pPr>
             <a:r>
@@ -8610,7 +8610,7 @@
           <a:bodyPr wrap="square" rtlCol="0" anchor="ctr"/>
           <a:lstStyle/>
           <a:p>
-            <a:pPr algn="l" indent="0" marL="0">
+            <a:pPr rtl="1" algn="l" indent="0" marL="0">
               <a:buNone/>
             </a:pPr>
             <a:r>
@@ -8681,7 +8681,7 @@
           <a:bodyPr wrap="square" rtlCol="0" anchor="ctr"/>
           <a:lstStyle/>
           <a:p>
-            <a:pPr algn="r" indent="0" marL="0">
+            <a:pPr rtl="1" algn="r" indent="0" marL="0">
               <a:buNone/>
             </a:pPr>
             <a:r>
@@ -8720,7 +8720,7 @@
           <a:bodyPr wrap="square" rtlCol="0" anchor="t"/>
           <a:lstStyle/>
           <a:p>
-            <a:pPr algn="r" indent="0" marL="0">
+            <a:pPr rtl="1" algn="r" indent="0" marL="0">
               <a:buNone/>
             </a:pPr>
             <a:r>
@@ -8759,7 +8759,7 @@
           <a:bodyPr wrap="square" rtlCol="0" anchor="t"/>
           <a:lstStyle/>
           <a:p>
-            <a:pPr algn="r" indent="0" marL="0">
+            <a:pPr rtl="1" algn="r" indent="0" marL="0">
               <a:buNone/>
             </a:pPr>
             <a:r>
@@ -8855,7 +8855,7 @@
           <a:bodyPr wrap="square" lIns="0" tIns="0" rIns="0" bIns="0" rtlCol="0" anchor="ctr"/>
           <a:lstStyle/>
           <a:p>
-            <a:pPr algn="r" indent="0" marL="0">
+            <a:pPr rtl="1" algn="r" indent="0" marL="0">
               <a:buNone/>
             </a:pPr>
             <a:r>
@@ -8894,7 +8894,7 @@
           <a:bodyPr wrap="square" lIns="0" tIns="0" rIns="0" bIns="0" rtlCol="0" anchor="t"/>
           <a:lstStyle/>
           <a:p>
-            <a:pPr algn="r" indent="0" marL="0">
+            <a:pPr rtl="1" algn="r" indent="0" marL="0">
               <a:buNone/>
             </a:pPr>
             <a:r>
@@ -8933,7 +8933,7 @@
           <a:bodyPr wrap="square" lIns="0" tIns="0" rIns="0" bIns="0" rtlCol="0" anchor="t"/>
           <a:lstStyle/>
           <a:p>
-            <a:pPr algn="r" marL="152400" indent="-152400">
+            <a:pPr rtl="1" algn="r" marL="152400" indent="-152400">
               <a:spcAft>
                 <a:spcPts val="400"/>
               </a:spcAft>
@@ -8954,7 +8954,7 @@
             <a:endParaRPr lang="en-US" sz="950" dirty="0"/>
           </a:p>
           <a:p>
-            <a:pPr algn="r" marL="152400" indent="-152400">
+            <a:pPr rtl="1" algn="r" marL="152400" indent="-152400">
               <a:spcAft>
                 <a:spcPts val="400"/>
               </a:spcAft>
@@ -8975,7 +8975,7 @@
             <a:endParaRPr lang="en-US" sz="950" dirty="0"/>
           </a:p>
           <a:p>
-            <a:pPr algn="r" marL="152400" indent="-152400">
+            <a:pPr rtl="1" algn="r" marL="152400" indent="-152400">
               <a:spcAft>
                 <a:spcPts val="400"/>
               </a:spcAft>
@@ -9018,7 +9018,7 @@
           <a:bodyPr wrap="square" rtlCol="0" anchor="ctr"/>
           <a:lstStyle/>
           <a:p>
-            <a:pPr algn="ctr" indent="0" marL="0">
+            <a:pPr rtl="1" algn="ctr" indent="0" marL="0">
               <a:buNone/>
             </a:pPr>
             <a:r>
@@ -9091,7 +9091,7 @@
           <a:bodyPr wrap="square" lIns="0" tIns="0" rIns="0" bIns="0" rtlCol="0" anchor="ctr"/>
           <a:lstStyle/>
           <a:p>
-            <a:pPr algn="r" indent="0" marL="0">
+            <a:pPr rtl="1" algn="r" indent="0" marL="0">
               <a:buNone/>
             </a:pPr>
             <a:r>
@@ -9130,7 +9130,7 @@
           <a:bodyPr wrap="square" lIns="0" tIns="0" rIns="0" bIns="0" rtlCol="0" anchor="t"/>
           <a:lstStyle/>
           <a:p>
-            <a:pPr algn="r" indent="0" marL="0">
+            <a:pPr rtl="1" algn="r" indent="0" marL="0">
               <a:buNone/>
             </a:pPr>
             <a:r>
@@ -9169,7 +9169,7 @@
           <a:bodyPr wrap="square" lIns="0" tIns="0" rIns="0" bIns="0" rtlCol="0" anchor="t"/>
           <a:lstStyle/>
           <a:p>
-            <a:pPr algn="r" marL="152400" indent="-152400">
+            <a:pPr rtl="1" algn="r" marL="152400" indent="-152400">
               <a:spcAft>
                 <a:spcPts val="400"/>
               </a:spcAft>
@@ -9190,7 +9190,7 @@
             <a:endParaRPr lang="en-US" sz="950" dirty="0"/>
           </a:p>
           <a:p>
-            <a:pPr algn="r" marL="152400" indent="-152400">
+            <a:pPr rtl="1" algn="r" marL="152400" indent="-152400">
               <a:spcAft>
                 <a:spcPts val="400"/>
               </a:spcAft>
@@ -9233,7 +9233,7 @@
           <a:bodyPr wrap="square" rtlCol="0" anchor="ctr"/>
           <a:lstStyle/>
           <a:p>
-            <a:pPr algn="ctr" indent="0" marL="0">
+            <a:pPr rtl="1" algn="ctr" indent="0" marL="0">
               <a:buNone/>
             </a:pPr>
             <a:r>
@@ -9306,7 +9306,7 @@
           <a:bodyPr wrap="square" lIns="0" tIns="0" rIns="0" bIns="0" rtlCol="0" anchor="ctr"/>
           <a:lstStyle/>
           <a:p>
-            <a:pPr algn="r" indent="0" marL="0">
+            <a:pPr rtl="1" algn="r" indent="0" marL="0">
               <a:buNone/>
             </a:pPr>
             <a:r>
@@ -9345,7 +9345,7 @@
           <a:bodyPr wrap="square" lIns="0" tIns="0" rIns="0" bIns="0" rtlCol="0" anchor="t"/>
           <a:lstStyle/>
           <a:p>
-            <a:pPr algn="r" indent="0" marL="0">
+            <a:pPr rtl="1" algn="r" indent="0" marL="0">
               <a:buNone/>
             </a:pPr>
             <a:r>
@@ -9384,7 +9384,7 @@
           <a:bodyPr wrap="square" lIns="0" tIns="0" rIns="0" bIns="0" rtlCol="0" anchor="t"/>
           <a:lstStyle/>
           <a:p>
-            <a:pPr algn="r" marL="152400" indent="-152400">
+            <a:pPr rtl="1" algn="r" marL="152400" indent="-152400">
               <a:spcAft>
                 <a:spcPts val="400"/>
               </a:spcAft>
@@ -9405,7 +9405,7 @@
             <a:endParaRPr lang="en-US" sz="950" dirty="0"/>
           </a:p>
           <a:p>
-            <a:pPr algn="r" marL="152400" indent="-152400">
+            <a:pPr rtl="1" algn="r" marL="152400" indent="-152400">
               <a:spcAft>
                 <a:spcPts val="400"/>
               </a:spcAft>
@@ -9448,7 +9448,7 @@
           <a:bodyPr wrap="square" rtlCol="0" anchor="ctr"/>
           <a:lstStyle/>
           <a:p>
-            <a:pPr algn="ctr" indent="0" marL="0">
+            <a:pPr rtl="1" algn="ctr" indent="0" marL="0">
               <a:buNone/>
             </a:pPr>
             <a:r>
@@ -9521,7 +9521,7 @@
           <a:bodyPr wrap="square" lIns="0" tIns="0" rIns="0" bIns="0" rtlCol="0" anchor="ctr"/>
           <a:lstStyle/>
           <a:p>
-            <a:pPr algn="r" indent="0" marL="0">
+            <a:pPr rtl="1" algn="r" indent="0" marL="0">
               <a:buNone/>
             </a:pPr>
             <a:r>
@@ -9560,7 +9560,7 @@
           <a:bodyPr wrap="square" lIns="0" tIns="0" rIns="0" bIns="0" rtlCol="0" anchor="t"/>
           <a:lstStyle/>
           <a:p>
-            <a:pPr algn="r" indent="0" marL="0">
+            <a:pPr rtl="1" algn="r" indent="0" marL="0">
               <a:buNone/>
             </a:pPr>
             <a:r>
@@ -9599,7 +9599,7 @@
           <a:bodyPr wrap="square" lIns="0" tIns="0" rIns="0" bIns="0" rtlCol="0" anchor="t"/>
           <a:lstStyle/>
           <a:p>
-            <a:pPr algn="r" marL="152400" indent="-152400">
+            <a:pPr rtl="1" algn="r" marL="152400" indent="-152400">
               <a:spcAft>
                 <a:spcPts val="400"/>
               </a:spcAft>
@@ -9620,7 +9620,7 @@
             <a:endParaRPr lang="en-US" sz="950" dirty="0"/>
           </a:p>
           <a:p>
-            <a:pPr algn="r" marL="152400" indent="-152400">
+            <a:pPr rtl="1" algn="r" marL="152400" indent="-152400">
               <a:spcAft>
                 <a:spcPts val="400"/>
               </a:spcAft>
@@ -9697,7 +9697,7 @@
           <a:bodyPr wrap="square" lIns="0" tIns="0" rIns="0" bIns="0" rtlCol="0" anchor="ctr"/>
           <a:lstStyle/>
           <a:p>
-            <a:pPr algn="r" indent="0" marL="0">
+            <a:pPr rtl="1" algn="r" indent="0" marL="0">
               <a:buNone/>
             </a:pPr>
             <a:r>
@@ -9736,7 +9736,7 @@
           <a:bodyPr wrap="square" lIns="0" tIns="0" rIns="0" bIns="0" rtlCol="0" anchor="t"/>
           <a:lstStyle/>
           <a:p>
-            <a:pPr algn="r" indent="0" marL="0">
+            <a:pPr rtl="1" algn="r" indent="0" marL="0">
               <a:buNone/>
             </a:pPr>
             <a:r>
@@ -9775,7 +9775,7 @@
           <a:bodyPr wrap="square" rtlCol="0" anchor="ctr"/>
           <a:lstStyle/>
           <a:p>
-            <a:pPr algn="l" indent="0" marL="0">
+            <a:pPr rtl="1" algn="l" indent="0" marL="0">
               <a:buNone/>
             </a:pPr>
             <a:r>
@@ -9846,7 +9846,7 @@
           <a:bodyPr wrap="square" rtlCol="0" anchor="ctr"/>
           <a:lstStyle/>
           <a:p>
-            <a:pPr algn="r" indent="0" marL="0">
+            <a:pPr rtl="1" algn="r" indent="0" marL="0">
               <a:buNone/>
             </a:pPr>
             <a:r>
@@ -9885,7 +9885,7 @@
           <a:bodyPr wrap="square" rtlCol="0" anchor="t"/>
           <a:lstStyle/>
           <a:p>
-            <a:pPr algn="r" indent="0" marL="0">
+            <a:pPr rtl="1" algn="r" indent="0" marL="0">
               <a:buNone/>
             </a:pPr>
             <a:r>
@@ -9981,7 +9981,7 @@
           <a:bodyPr wrap="square" lIns="0" tIns="0" rIns="0" bIns="0" rtlCol="0" anchor="ctr"/>
           <a:lstStyle/>
           <a:p>
-            <a:pPr algn="r" indent="0" marL="0">
+            <a:pPr rtl="1" algn="r" indent="0" marL="0">
               <a:buNone/>
             </a:pPr>
             <a:r>
@@ -10020,7 +10020,7 @@
           <a:bodyPr wrap="square" lIns="0" tIns="0" rIns="0" bIns="0" rtlCol="0" anchor="t"/>
           <a:lstStyle/>
           <a:p>
-            <a:pPr algn="r" indent="0" marL="0">
+            <a:pPr rtl="1" algn="r" indent="0" marL="0">
               <a:buNone/>
             </a:pPr>
             <a:r>
@@ -10093,7 +10093,7 @@
           <a:bodyPr wrap="square" lIns="0" tIns="0" rIns="0" bIns="0" rtlCol="0" anchor="ctr"/>
           <a:lstStyle/>
           <a:p>
-            <a:pPr algn="r" indent="0" marL="0">
+            <a:pPr rtl="1" algn="r" indent="0" marL="0">
               <a:buNone/>
             </a:pPr>
             <a:r>
@@ -10132,7 +10132,7 @@
           <a:bodyPr wrap="square" lIns="0" tIns="0" rIns="0" bIns="0" rtlCol="0" anchor="t"/>
           <a:lstStyle/>
           <a:p>
-            <a:pPr algn="r" indent="0" marL="0">
+            <a:pPr rtl="1" algn="r" indent="0" marL="0">
               <a:buNone/>
             </a:pPr>
             <a:r>
@@ -10205,7 +10205,7 @@
           <a:bodyPr wrap="square" lIns="0" tIns="0" rIns="0" bIns="0" rtlCol="0" anchor="ctr"/>
           <a:lstStyle/>
           <a:p>
-            <a:pPr algn="r" indent="0" marL="0">
+            <a:pPr rtl="1" algn="r" indent="0" marL="0">
               <a:buNone/>
             </a:pPr>
             <a:r>
@@ -10244,7 +10244,7 @@
           <a:bodyPr wrap="square" lIns="0" tIns="0" rIns="0" bIns="0" rtlCol="0" anchor="t"/>
           <a:lstStyle/>
           <a:p>
-            <a:pPr algn="r" indent="0" marL="0">
+            <a:pPr rtl="1" algn="r" indent="0" marL="0">
               <a:buNone/>
             </a:pPr>
             <a:r>
@@ -10317,7 +10317,7 @@
           <a:bodyPr wrap="square" lIns="0" tIns="0" rIns="0" bIns="0" rtlCol="0" anchor="ctr"/>
           <a:lstStyle/>
           <a:p>
-            <a:pPr algn="r" indent="0" marL="0">
+            <a:pPr rtl="1" algn="r" indent="0" marL="0">
               <a:buNone/>
             </a:pPr>
             <a:r>
@@ -10356,7 +10356,7 @@
           <a:bodyPr wrap="square" lIns="0" tIns="0" rIns="0" bIns="0" rtlCol="0" anchor="t"/>
           <a:lstStyle/>
           <a:p>
-            <a:pPr algn="r" indent="0" marL="0">
+            <a:pPr rtl="1" algn="r" indent="0" marL="0">
               <a:buNone/>
             </a:pPr>
             <a:r>
@@ -10395,7 +10395,7 @@
           <a:bodyPr wrap="square" rtlCol="0" anchor="ctr"/>
           <a:lstStyle/>
           <a:p>
-            <a:pPr algn="l" indent="0" marL="0">
+            <a:pPr rtl="1" algn="l" indent="0" marL="0">
               <a:buNone/>
             </a:pPr>
             <a:r>
@@ -10466,7 +10466,7 @@
           <a:bodyPr wrap="square" rtlCol="0" anchor="ctr"/>
           <a:lstStyle/>
           <a:p>
-            <a:pPr algn="r" indent="0" marL="0">
+            <a:pPr rtl="1" algn="r" indent="0" marL="0">
               <a:buNone/>
             </a:pPr>
             <a:r>
@@ -10505,7 +10505,7 @@
           <a:bodyPr wrap="square" rtlCol="0" anchor="t"/>
           <a:lstStyle/>
           <a:p>
-            <a:pPr algn="r" indent="0" marL="0">
+            <a:pPr rtl="1" algn="r" indent="0" marL="0">
               <a:buNone/>
             </a:pPr>
             <a:r>
@@ -10601,7 +10601,7 @@
           <a:bodyPr wrap="square" lIns="0" tIns="0" rIns="0" bIns="0" rtlCol="0" anchor="t"/>
           <a:lstStyle/>
           <a:p>
-            <a:pPr algn="r" indent="0" marL="0">
+            <a:pPr rtl="1" algn="r" indent="0" marL="0">
               <a:buNone/>
             </a:pPr>
             <a:r>
@@ -10674,7 +10674,7 @@
           <a:bodyPr wrap="square" lIns="0" tIns="0" rIns="0" bIns="0" rtlCol="0" anchor="t"/>
           <a:lstStyle/>
           <a:p>
-            <a:pPr algn="r" indent="0" marL="0">
+            <a:pPr rtl="1" algn="r" indent="0" marL="0">
               <a:buNone/>
             </a:pPr>
             <a:r>
@@ -10688,7 +10688,7 @@
               </a:rPr>
               <a:t>איך זה מתעדכן: </a:t>
             </a:r>
-            <a:pPr algn="r" indent="0" marL="0">
+            <a:pPr rtl="1" algn="r" indent="0" marL="0">
               <a:buNone/>
             </a:pPr>
             <a:r>
@@ -10727,7 +10727,7 @@
           <a:bodyPr wrap="square" rtlCol="0" anchor="ctr"/>
           <a:lstStyle/>
           <a:p>
-            <a:pPr algn="l" indent="0" marL="0">
+            <a:pPr rtl="1" algn="l" indent="0" marL="0">
               <a:buNone/>
             </a:pPr>
             <a:r>
@@ -10798,7 +10798,7 @@
           <a:bodyPr wrap="square" rtlCol="0" anchor="ctr"/>
           <a:lstStyle/>
           <a:p>
-            <a:pPr algn="r" indent="0" marL="0">
+            <a:pPr rtl="1" algn="r" indent="0" marL="0">
               <a:buNone/>
             </a:pPr>
             <a:r>
@@ -10837,7 +10837,7 @@
           <a:bodyPr wrap="square" rtlCol="0" anchor="t"/>
           <a:lstStyle/>
           <a:p>
-            <a:pPr algn="r" indent="0" marL="0">
+            <a:pPr rtl="1" algn="r" indent="0" marL="0">
               <a:buNone/>
             </a:pPr>
             <a:r>
@@ -10876,7 +10876,7 @@
           <a:bodyPr wrap="square" rtlCol="0" anchor="t"/>
           <a:lstStyle/>
           <a:p>
-            <a:pPr algn="r" indent="0" marL="0">
+            <a:pPr rtl="1" algn="r" indent="0" marL="0">
               <a:buNone/>
             </a:pPr>
             <a:r>
@@ -10963,7 +10963,7 @@
           <a:bodyPr wrap="square" lIns="0" tIns="0" rIns="0" bIns="0" rtlCol="0" anchor="ctr"/>
           <a:lstStyle/>
           <a:p>
-            <a:pPr algn="ctr" indent="0" marL="0">
+            <a:pPr rtl="1" algn="ctr" indent="0" marL="0">
               <a:buNone/>
             </a:pPr>
             <a:r>
@@ -11002,7 +11002,7 @@
           <a:bodyPr wrap="square" lIns="0" tIns="0" rIns="0" bIns="0" rtlCol="0" anchor="t"/>
           <a:lstStyle/>
           <a:p>
-            <a:pPr algn="r" indent="0" marL="0">
+            <a:pPr rtl="1" algn="r" indent="0" marL="0">
               <a:buNone/>
             </a:pPr>
             <a:r>
@@ -11016,7 +11016,7 @@
               </a:rPr>
               <a:t>לפני כל קוד — לאמת מול המציאות.  </a:t>
             </a:r>
-            <a:pPr algn="r" indent="0" marL="0">
+            <a:pPr rtl="1" algn="r" indent="0" marL="0">
               <a:buNone/>
             </a:pPr>
             <a:r>
@@ -11080,7 +11080,7 @@
           <a:bodyPr wrap="square" lIns="0" tIns="0" rIns="0" bIns="0" rtlCol="0" anchor="ctr"/>
           <a:lstStyle/>
           <a:p>
-            <a:pPr algn="ctr" indent="0" marL="0">
+            <a:pPr rtl="1" algn="ctr" indent="0" marL="0">
               <a:buNone/>
             </a:pPr>
             <a:r>
@@ -11119,7 +11119,7 @@
           <a:bodyPr wrap="square" lIns="0" tIns="0" rIns="0" bIns="0" rtlCol="0" anchor="t"/>
           <a:lstStyle/>
           <a:p>
-            <a:pPr algn="r" indent="0" marL="0">
+            <a:pPr rtl="1" algn="r" indent="0" marL="0">
               <a:buNone/>
             </a:pPr>
             <a:r>
@@ -11133,7 +11133,7 @@
               </a:rPr>
               <a:t>שלב אחד, Definition of Done ברור.  </a:t>
             </a:r>
-            <a:pPr algn="r" indent="0" marL="0">
+            <a:pPr rtl="1" algn="r" indent="0" marL="0">
               <a:buNone/>
             </a:pPr>
             <a:r>
@@ -11197,7 +11197,7 @@
           <a:bodyPr wrap="square" lIns="0" tIns="0" rIns="0" bIns="0" rtlCol="0" anchor="ctr"/>
           <a:lstStyle/>
           <a:p>
-            <a:pPr algn="ctr" indent="0" marL="0">
+            <a:pPr rtl="1" algn="ctr" indent="0" marL="0">
               <a:buNone/>
             </a:pPr>
             <a:r>
@@ -11236,7 +11236,7 @@
           <a:bodyPr wrap="square" lIns="0" tIns="0" rIns="0" bIns="0" rtlCol="0" anchor="t"/>
           <a:lstStyle/>
           <a:p>
-            <a:pPr algn="r" indent="0" marL="0">
+            <a:pPr rtl="1" algn="r" indent="0" marL="0">
               <a:buNone/>
             </a:pPr>
             <a:r>
@@ -11250,7 +11250,7 @@
               </a:rPr>
               <a:t>בלי מספרים מומצאים.  </a:t>
             </a:r>
-            <a:pPr algn="r" indent="0" marL="0">
+            <a:pPr rtl="1" algn="r" indent="0" marL="0">
               <a:buNone/>
             </a:pPr>
             <a:r>
@@ -11314,7 +11314,7 @@
           <a:bodyPr wrap="square" lIns="0" tIns="0" rIns="0" bIns="0" rtlCol="0" anchor="ctr"/>
           <a:lstStyle/>
           <a:p>
-            <a:pPr algn="ctr" indent="0" marL="0">
+            <a:pPr rtl="1" algn="ctr" indent="0" marL="0">
               <a:buNone/>
             </a:pPr>
             <a:r>
@@ -11353,7 +11353,7 @@
           <a:bodyPr wrap="square" lIns="0" tIns="0" rIns="0" bIns="0" rtlCol="0" anchor="t"/>
           <a:lstStyle/>
           <a:p>
-            <a:pPr algn="r" indent="0" marL="0">
+            <a:pPr rtl="1" algn="r" indent="0" marL="0">
               <a:buNone/>
             </a:pPr>
             <a:r>
@@ -11367,7 +11367,7 @@
               </a:rPr>
               <a:t>בדיקת טיפוסים ירוקה ≠ הקוד עובד.  </a:t>
             </a:r>
-            <a:pPr algn="r" indent="0" marL="0">
+            <a:pPr rtl="1" algn="r" indent="0" marL="0">
               <a:buNone/>
             </a:pPr>
             <a:r>
@@ -11431,7 +11431,7 @@
           <a:bodyPr wrap="square" lIns="0" tIns="0" rIns="0" bIns="0" rtlCol="0" anchor="ctr"/>
           <a:lstStyle/>
           <a:p>
-            <a:pPr algn="ctr" indent="0" marL="0">
+            <a:pPr rtl="1" algn="ctr" indent="0" marL="0">
               <a:buNone/>
             </a:pPr>
             <a:r>
@@ -11470,7 +11470,7 @@
           <a:bodyPr wrap="square" lIns="0" tIns="0" rIns="0" bIns="0" rtlCol="0" anchor="t"/>
           <a:lstStyle/>
           <a:p>
-            <a:pPr algn="r" indent="0" marL="0">
+            <a:pPr rtl="1" algn="r" indent="0" marL="0">
               <a:buNone/>
             </a:pPr>
             <a:r>
@@ -11484,7 +11484,7 @@
               </a:rPr>
               <a:t>גיט כתיעוד, לא רק גיבוי.  </a:t>
             </a:r>
-            <a:pPr algn="r" indent="0" marL="0">
+            <a:pPr rtl="1" algn="r" indent="0" marL="0">
               <a:buNone/>
             </a:pPr>
             <a:r>
@@ -11579,7 +11579,7 @@
           <a:bodyPr wrap="square" lIns="0" tIns="0" rIns="0" bIns="0" rtlCol="0" anchor="ctr"/>
           <a:lstStyle/>
           <a:p>
-            <a:pPr algn="r" indent="0" marL="0">
+            <a:pPr rtl="1" algn="r" indent="0" marL="0">
               <a:buNone/>
             </a:pPr>
             <a:r>
@@ -11618,7 +11618,7 @@
           <a:bodyPr wrap="square" lIns="0" tIns="0" rIns="0" bIns="0" rtlCol="0" anchor="t"/>
           <a:lstStyle/>
           <a:p>
-            <a:pPr algn="r" indent="0" marL="0">
+            <a:pPr rtl="1" algn="r" indent="0" marL="0">
               <a:spcAft>
                 <a:spcPts val="600"/>
               </a:spcAft>
@@ -11635,7 +11635,7 @@
               </a:rPr>
               <a:t>לא ניחשתי. </a:t>
             </a:r>
-            <a:pPr algn="r" indent="0" marL="0">
+            <a:pPr rtl="1" algn="r" indent="0" marL="0">
               <a:spcAft>
                 <a:spcPts val="600"/>
               </a:spcAft>
@@ -11652,7 +11652,7 @@
               </a:rPr>
               <a:t>בדקתי טבלת לוגים (ריקה לגמרי), ואז שלחתי קריאה אמיתית לפונקציה החיה וראיתי את השגיאה המדויקת: ANTHROPIC_API_KEY is not set.</a:t>
             </a:r>
-            <a:pPr algn="r" indent="0" marL="0">
+            <a:pPr rtl="1" algn="r" indent="0" marL="0">
               <a:spcAft>
                 <a:spcPts val="600"/>
               </a:spcAft>
@@ -11661,7 +11661,7 @@
             <a:endParaRPr lang="en-US" sz="1100" dirty="0"/>
           </a:p>
           <a:p>
-            <a:pPr algn="r" indent="0" marL="0">
+            <a:pPr rtl="1" algn="r" indent="0" marL="0">
               <a:spcAft>
                 <a:spcPts val="600"/>
               </a:spcAft>
@@ -11681,7 +11681,7 @@
             <a:endParaRPr lang="en-US" sz="1100" dirty="0"/>
           </a:p>
           <a:p>
-            <a:pPr algn="r" indent="0" marL="0">
+            <a:pPr rtl="1" algn="r" indent="0" marL="0">
               <a:spcAft>
                 <a:spcPts val="600"/>
               </a:spcAft>
@@ -11723,7 +11723,7 @@
           <a:bodyPr wrap="square" rtlCol="0" anchor="ctr"/>
           <a:lstStyle/>
           <a:p>
-            <a:pPr algn="l" indent="0" marL="0">
+            <a:pPr rtl="1" algn="l" indent="0" marL="0">
               <a:buNone/>
             </a:pPr>
             <a:r>
@@ -11794,7 +11794,7 @@
           <a:bodyPr wrap="square" rtlCol="0" anchor="ctr"/>
           <a:lstStyle/>
           <a:p>
-            <a:pPr algn="r" indent="0" marL="0">
+            <a:pPr rtl="1" algn="r" indent="0" marL="0">
               <a:buNone/>
             </a:pPr>
             <a:r>
@@ -11833,7 +11833,7 @@
           <a:bodyPr wrap="square" rtlCol="0" anchor="t"/>
           <a:lstStyle/>
           <a:p>
-            <a:pPr algn="r" indent="0" marL="0">
+            <a:pPr rtl="1" algn="r" indent="0" marL="0">
               <a:buNone/>
             </a:pPr>
             <a:r>
@@ -11922,7 +11922,7 @@
           <a:bodyPr wrap="square" lIns="0" tIns="0" rIns="0" bIns="0" rtlCol="0" anchor="ctr"/>
           <a:lstStyle/>
           <a:p>
-            <a:pPr algn="ctr" indent="0" marL="0">
+            <a:pPr rtl="1" algn="ctr" indent="0" marL="0">
               <a:buNone/>
             </a:pPr>
             <a:r>
@@ -11988,7 +11988,7 @@
           <a:bodyPr wrap="square" lIns="0" tIns="0" rIns="0" bIns="0" rtlCol="0" anchor="ctr"/>
           <a:lstStyle/>
           <a:p>
-            <a:pPr algn="ctr" indent="0" marL="0">
+            <a:pPr rtl="1" algn="ctr" indent="0" marL="0">
               <a:buNone/>
             </a:pPr>
             <a:r>
@@ -12054,7 +12054,7 @@
           <a:bodyPr wrap="square" lIns="0" tIns="0" rIns="0" bIns="0" rtlCol="0" anchor="ctr"/>
           <a:lstStyle/>
           <a:p>
-            <a:pPr algn="ctr" indent="0" marL="0">
+            <a:pPr rtl="1" algn="ctr" indent="0" marL="0">
               <a:buNone/>
             </a:pPr>
             <a:r>
@@ -12120,7 +12120,7 @@
           <a:bodyPr wrap="square" lIns="0" tIns="0" rIns="0" bIns="0" rtlCol="0" anchor="ctr"/>
           <a:lstStyle/>
           <a:p>
-            <a:pPr algn="ctr" indent="0" marL="0">
+            <a:pPr rtl="1" algn="ctr" indent="0" marL="0">
               <a:buNone/>
             </a:pPr>
             <a:r>
@@ -12186,7 +12186,7 @@
           <a:bodyPr wrap="square" lIns="0" tIns="0" rIns="0" bIns="0" rtlCol="0" anchor="ctr"/>
           <a:lstStyle/>
           <a:p>
-            <a:pPr algn="ctr" indent="0" marL="0">
+            <a:pPr rtl="1" algn="ctr" indent="0" marL="0">
               <a:buNone/>
             </a:pPr>
             <a:r>
@@ -12252,7 +12252,7 @@
           <a:bodyPr wrap="square" lIns="0" tIns="0" rIns="0" bIns="0" rtlCol="0" anchor="ctr"/>
           <a:lstStyle/>
           <a:p>
-            <a:pPr algn="ctr" indent="0" marL="0">
+            <a:pPr rtl="1" algn="ctr" indent="0" marL="0">
               <a:buNone/>
             </a:pPr>
             <a:r>
@@ -12291,7 +12291,7 @@
           <a:bodyPr wrap="square" rtlCol="0" anchor="ctr"/>
           <a:lstStyle/>
           <a:p>
-            <a:pPr algn="r" indent="0" marL="0">
+            <a:pPr rtl="1" algn="r" indent="0" marL="0">
               <a:buNone/>
             </a:pPr>
             <a:r>
@@ -12359,7 +12359,7 @@
           <a:bodyPr wrap="square" lIns="0" tIns="0" rIns="0" bIns="0" rtlCol="0" anchor="t"/>
           <a:lstStyle/>
           <a:p>
-            <a:pPr algn="r" indent="0" marL="0">
+            <a:pPr rtl="1" algn="r" indent="0" marL="0">
               <a:lnSpc>
                 <a:spcPct val="130000"/>
               </a:lnSpc>
@@ -12379,7 +12379,7 @@
             <a:endParaRPr lang="en-US" sz="1250" dirty="0"/>
           </a:p>
           <a:p>
-            <a:pPr algn="r" indent="0" marL="0">
+            <a:pPr rtl="1" algn="r" indent="0" marL="0">
               <a:lnSpc>
                 <a:spcPct val="130000"/>
               </a:lnSpc>
@@ -12388,7 +12388,7 @@
             <a:endParaRPr lang="en-US" sz="1250" dirty="0"/>
           </a:p>
           <a:p>
-            <a:pPr algn="r" indent="0" marL="0">
+            <a:pPr rtl="1" algn="r" indent="0" marL="0">
               <a:lnSpc>
                 <a:spcPct val="130000"/>
               </a:lnSpc>
@@ -12408,7 +12408,7 @@
             <a:endParaRPr lang="en-US" sz="1250" dirty="0"/>
           </a:p>
           <a:p>
-            <a:pPr algn="r" indent="0" marL="0">
+            <a:pPr rtl="1" algn="r" indent="0" marL="0">
               <a:lnSpc>
                 <a:spcPct val="130000"/>
               </a:lnSpc>
@@ -12428,7 +12428,7 @@
             <a:endParaRPr lang="en-US" sz="1250" dirty="0"/>
           </a:p>
           <a:p>
-            <a:pPr algn="r" indent="0" marL="0">
+            <a:pPr rtl="1" algn="r" indent="0" marL="0">
               <a:lnSpc>
                 <a:spcPct val="130000"/>
               </a:lnSpc>
@@ -12448,7 +12448,7 @@
             <a:endParaRPr lang="en-US" sz="1250" dirty="0"/>
           </a:p>
           <a:p>
-            <a:pPr algn="r" indent="0" marL="0">
+            <a:pPr rtl="1" algn="r" indent="0" marL="0">
               <a:lnSpc>
                 <a:spcPct val="130000"/>
               </a:lnSpc>
@@ -12468,7 +12468,7 @@
             <a:endParaRPr lang="en-US" sz="1250" dirty="0"/>
           </a:p>
           <a:p>
-            <a:pPr algn="r" indent="0" marL="0">
+            <a:pPr rtl="1" algn="r" indent="0" marL="0">
               <a:lnSpc>
                 <a:spcPct val="130000"/>
               </a:lnSpc>
@@ -12488,7 +12488,7 @@
             <a:endParaRPr lang="en-US" sz="1250" dirty="0"/>
           </a:p>
           <a:p>
-            <a:pPr algn="r" indent="0" marL="0">
+            <a:pPr rtl="1" algn="r" indent="0" marL="0">
               <a:lnSpc>
                 <a:spcPct val="130000"/>
               </a:lnSpc>
@@ -12497,7 +12497,7 @@
             <a:endParaRPr lang="en-US" sz="1250" dirty="0"/>
           </a:p>
           <a:p>
-            <a:pPr algn="r" indent="0" marL="0">
+            <a:pPr rtl="1" algn="r" indent="0" marL="0">
               <a:lnSpc>
                 <a:spcPct val="130000"/>
               </a:lnSpc>
@@ -12539,7 +12539,7 @@
           <a:bodyPr wrap="square" rtlCol="0" anchor="ctr"/>
           <a:lstStyle/>
           <a:p>
-            <a:pPr algn="l" indent="0" marL="0">
+            <a:pPr rtl="1" algn="l" indent="0" marL="0">
               <a:buNone/>
             </a:pPr>
             <a:r>
@@ -12610,7 +12610,7 @@
           <a:bodyPr wrap="square" rtlCol="0" anchor="ctr"/>
           <a:lstStyle/>
           <a:p>
-            <a:pPr algn="r" indent="0" marL="0">
+            <a:pPr rtl="1" algn="r" indent="0" marL="0">
               <a:buNone/>
             </a:pPr>
             <a:r>
@@ -12649,7 +12649,7 @@
           <a:bodyPr wrap="square" rtlCol="0" anchor="t"/>
           <a:lstStyle/>
           <a:p>
-            <a:pPr algn="r" indent="0" marL="0">
+            <a:pPr rtl="1" algn="r" indent="0" marL="0">
               <a:buNone/>
             </a:pPr>
             <a:r>
@@ -12688,7 +12688,7 @@
           <a:bodyPr wrap="square" rtlCol="0" anchor="t"/>
           <a:lstStyle/>
           <a:p>
-            <a:pPr algn="r" indent="0" marL="0">
+            <a:pPr rtl="1" algn="r" indent="0" marL="0">
               <a:buNone/>
             </a:pPr>
             <a:r>
@@ -12779,7 +12779,7 @@
           <a:bodyPr wrap="square" lIns="0" tIns="0" rIns="0" bIns="0" rtlCol="0" anchor="t"/>
           <a:lstStyle/>
           <a:p>
-            <a:pPr algn="r" indent="0" marL="0">
+            <a:pPr rtl="1" algn="r" indent="0" marL="0">
               <a:lnSpc>
                 <a:spcPct val="125000"/>
               </a:lnSpc>
@@ -12799,7 +12799,7 @@
             <a:endParaRPr lang="en-US" sz="1050" dirty="0"/>
           </a:p>
           <a:p>
-            <a:pPr algn="r" indent="0" marL="0">
+            <a:pPr rtl="1" algn="r" indent="0" marL="0">
               <a:lnSpc>
                 <a:spcPct val="125000"/>
               </a:lnSpc>
@@ -12808,7 +12808,7 @@
             <a:endParaRPr lang="en-US" sz="1050" dirty="0"/>
           </a:p>
           <a:p>
-            <a:pPr algn="r" indent="0" marL="0">
+            <a:pPr rtl="1" algn="r" indent="0" marL="0">
               <a:lnSpc>
                 <a:spcPct val="125000"/>
               </a:lnSpc>
@@ -12828,7 +12828,7 @@
             <a:endParaRPr lang="en-US" sz="1050" dirty="0"/>
           </a:p>
           <a:p>
-            <a:pPr algn="r" indent="0" marL="0">
+            <a:pPr rtl="1" algn="r" indent="0" marL="0">
               <a:lnSpc>
                 <a:spcPct val="125000"/>
               </a:lnSpc>
@@ -12848,7 +12848,7 @@
             <a:endParaRPr lang="en-US" sz="1050" dirty="0"/>
           </a:p>
           <a:p>
-            <a:pPr algn="r" indent="0" marL="0">
+            <a:pPr rtl="1" algn="r" indent="0" marL="0">
               <a:lnSpc>
                 <a:spcPct val="125000"/>
               </a:lnSpc>
@@ -12868,7 +12868,7 @@
             <a:endParaRPr lang="en-US" sz="1050" dirty="0"/>
           </a:p>
           <a:p>
-            <a:pPr algn="r" indent="0" marL="0">
+            <a:pPr rtl="1" algn="r" indent="0" marL="0">
               <a:lnSpc>
                 <a:spcPct val="125000"/>
               </a:lnSpc>
@@ -12888,7 +12888,7 @@
             <a:endParaRPr lang="en-US" sz="1050" dirty="0"/>
           </a:p>
           <a:p>
-            <a:pPr algn="r" indent="0" marL="0">
+            <a:pPr rtl="1" algn="r" indent="0" marL="0">
               <a:lnSpc>
                 <a:spcPct val="125000"/>
               </a:lnSpc>
@@ -12908,7 +12908,7 @@
             <a:endParaRPr lang="en-US" sz="1050" dirty="0"/>
           </a:p>
           <a:p>
-            <a:pPr algn="r" indent="0" marL="0">
+            <a:pPr rtl="1" algn="r" indent="0" marL="0">
               <a:lnSpc>
                 <a:spcPct val="125000"/>
               </a:lnSpc>
@@ -12928,7 +12928,7 @@
             <a:endParaRPr lang="en-US" sz="1050" dirty="0"/>
           </a:p>
           <a:p>
-            <a:pPr algn="r" indent="0" marL="0">
+            <a:pPr rtl="1" algn="r" indent="0" marL="0">
               <a:lnSpc>
                 <a:spcPct val="125000"/>
               </a:lnSpc>
@@ -12948,7 +12948,7 @@
             <a:endParaRPr lang="en-US" sz="1050" dirty="0"/>
           </a:p>
           <a:p>
-            <a:pPr algn="r" indent="0" marL="0">
+            <a:pPr rtl="1" algn="r" indent="0" marL="0">
               <a:lnSpc>
                 <a:spcPct val="125000"/>
               </a:lnSpc>
@@ -13024,7 +13024,7 @@
           <a:bodyPr wrap="square" lIns="0" tIns="0" rIns="0" bIns="0" rtlCol="0" anchor="ctr"/>
           <a:lstStyle/>
           <a:p>
-            <a:pPr algn="r" indent="0" marL="0">
+            <a:pPr rtl="1" algn="r" indent="0" marL="0">
               <a:buNone/>
             </a:pPr>
             <a:r>
@@ -13063,7 +13063,7 @@
           <a:bodyPr wrap="square" lIns="0" tIns="0" rIns="0" bIns="0" rtlCol="0" anchor="t"/>
           <a:lstStyle/>
           <a:p>
-            <a:pPr algn="r" indent="0" marL="0">
+            <a:pPr rtl="1" algn="r" indent="0" marL="0">
               <a:buNone/>
             </a:pPr>
             <a:r>
@@ -13136,7 +13136,7 @@
           <a:bodyPr wrap="square" lIns="0" tIns="0" rIns="0" bIns="0" rtlCol="0" anchor="ctr"/>
           <a:lstStyle/>
           <a:p>
-            <a:pPr algn="r" indent="0" marL="0">
+            <a:pPr rtl="1" algn="r" indent="0" marL="0">
               <a:buNone/>
             </a:pPr>
             <a:r>
@@ -13175,7 +13175,7 @@
           <a:bodyPr wrap="square" lIns="0" tIns="0" rIns="0" bIns="0" rtlCol="0" anchor="t"/>
           <a:lstStyle/>
           <a:p>
-            <a:pPr algn="r" indent="0" marL="0">
+            <a:pPr rtl="1" algn="r" indent="0" marL="0">
               <a:buNone/>
             </a:pPr>
             <a:r>
@@ -13248,7 +13248,7 @@
           <a:bodyPr wrap="square" lIns="0" tIns="0" rIns="0" bIns="0" rtlCol="0" anchor="ctr"/>
           <a:lstStyle/>
           <a:p>
-            <a:pPr algn="r" indent="0" marL="0">
+            <a:pPr rtl="1" algn="r" indent="0" marL="0">
               <a:buNone/>
             </a:pPr>
             <a:r>
@@ -13287,7 +13287,7 @@
           <a:bodyPr wrap="square" lIns="0" tIns="0" rIns="0" bIns="0" rtlCol="0" anchor="t"/>
           <a:lstStyle/>
           <a:p>
-            <a:pPr algn="r" indent="0" marL="0">
+            <a:pPr rtl="1" algn="r" indent="0" marL="0">
               <a:buNone/>
             </a:pPr>
             <a:r>
@@ -13326,7 +13326,7 @@
           <a:bodyPr wrap="square" rtlCol="0" anchor="ctr"/>
           <a:lstStyle/>
           <a:p>
-            <a:pPr algn="l" indent="0" marL="0">
+            <a:pPr rtl="1" algn="l" indent="0" marL="0">
               <a:buNone/>
             </a:pPr>
             <a:r>
@@ -13397,7 +13397,7 @@
           <a:bodyPr wrap="square" rtlCol="0" anchor="ctr"/>
           <a:lstStyle/>
           <a:p>
-            <a:pPr algn="r" indent="0" marL="0">
+            <a:pPr rtl="1" algn="r" indent="0" marL="0">
               <a:buNone/>
             </a:pPr>
             <a:r>
@@ -13436,7 +13436,7 @@
           <a:bodyPr wrap="square" rtlCol="0" anchor="t"/>
           <a:lstStyle/>
           <a:p>
-            <a:pPr algn="r" indent="0" marL="0">
+            <a:pPr rtl="1" algn="r" indent="0" marL="0">
               <a:buNone/>
             </a:pPr>
             <a:r>
@@ -13475,7 +13475,7 @@
           <a:bodyPr wrap="square" rtlCol="0" anchor="t"/>
           <a:lstStyle/>
           <a:p>
-            <a:pPr algn="r" indent="0" marL="0">
+            <a:pPr rtl="1" algn="r" indent="0" marL="0">
               <a:buNone/>
             </a:pPr>
             <a:r>
@@ -13551,7 +13551,7 @@
                     <a:bodyPr/>
                     <a:lstStyle/>
                     <a:p>
-                      <a:pPr algn="r" indent="0" marL="0">
+                      <a:pPr rtl="1" algn="r" indent="0" marL="0">
                         <a:buNone/>
                       </a:pPr>
                       <a:r>
@@ -13619,7 +13619,7 @@
                     <a:bodyPr/>
                     <a:lstStyle/>
                     <a:p>
-                      <a:pPr algn="r" indent="0" marL="0">
+                      <a:pPr rtl="1" algn="r" indent="0" marL="0">
                         <a:buNone/>
                       </a:pPr>
                       <a:r>
@@ -13687,7 +13687,7 @@
                     <a:bodyPr/>
                     <a:lstStyle/>
                     <a:p>
-                      <a:pPr algn="r" indent="0" marL="0">
+                      <a:pPr rtl="1" algn="r" indent="0" marL="0">
                         <a:buNone/>
                       </a:pPr>
                       <a:r>
@@ -13755,7 +13755,7 @@
                     <a:bodyPr/>
                     <a:lstStyle/>
                     <a:p>
-                      <a:pPr algn="r" indent="0" marL="0">
+                      <a:pPr rtl="1" algn="r" indent="0" marL="0">
                         <a:buNone/>
                       </a:pPr>
                       <a:r>
@@ -13823,7 +13823,7 @@
                     <a:bodyPr/>
                     <a:lstStyle/>
                     <a:p>
-                      <a:pPr algn="r" indent="0" marL="0">
+                      <a:pPr rtl="1" algn="r" indent="0" marL="0">
                         <a:buNone/>
                       </a:pPr>
                       <a:r>
@@ -13893,7 +13893,7 @@
                     <a:bodyPr/>
                     <a:lstStyle/>
                     <a:p>
-                      <a:pPr algn="r" indent="0" marL="0">
+                      <a:pPr rtl="1" algn="r" indent="0" marL="0">
                         <a:buNone/>
                       </a:pPr>
                       <a:r>
@@ -13961,7 +13961,7 @@
                     <a:bodyPr/>
                     <a:lstStyle/>
                     <a:p>
-                      <a:pPr algn="r" indent="0" marL="0">
+                      <a:pPr rtl="1" algn="r" indent="0" marL="0">
                         <a:buNone/>
                       </a:pPr>
                       <a:r>
@@ -14029,7 +14029,7 @@
                     <a:bodyPr/>
                     <a:lstStyle/>
                     <a:p>
-                      <a:pPr algn="r" indent="0" marL="0">
+                      <a:pPr rtl="1" algn="r" indent="0" marL="0">
                         <a:buNone/>
                       </a:pPr>
                       <a:r>
@@ -14097,7 +14097,7 @@
                     <a:bodyPr/>
                     <a:lstStyle/>
                     <a:p>
-                      <a:pPr algn="r" indent="0" marL="0">
+                      <a:pPr rtl="1" algn="r" indent="0" marL="0">
                         <a:buNone/>
                       </a:pPr>
                       <a:r>
@@ -14165,7 +14165,7 @@
                     <a:bodyPr/>
                     <a:lstStyle/>
                     <a:p>
-                      <a:pPr algn="r" indent="0" marL="0">
+                      <a:pPr rtl="1" algn="r" indent="0" marL="0">
                         <a:buNone/>
                       </a:pPr>
                       <a:r>
@@ -14235,7 +14235,7 @@
                     <a:bodyPr/>
                     <a:lstStyle/>
                     <a:p>
-                      <a:pPr algn="r" indent="0" marL="0">
+                      <a:pPr rtl="1" algn="r" indent="0" marL="0">
                         <a:buNone/>
                       </a:pPr>
                       <a:r>
@@ -14303,7 +14303,7 @@
                     <a:bodyPr/>
                     <a:lstStyle/>
                     <a:p>
-                      <a:pPr algn="r" indent="0" marL="0">
+                      <a:pPr rtl="1" algn="r" indent="0" marL="0">
                         <a:buNone/>
                       </a:pPr>
                       <a:r>
@@ -14371,7 +14371,7 @@
                     <a:bodyPr/>
                     <a:lstStyle/>
                     <a:p>
-                      <a:pPr algn="r" indent="0" marL="0">
+                      <a:pPr rtl="1" algn="r" indent="0" marL="0">
                         <a:buNone/>
                       </a:pPr>
                       <a:r>
@@ -14439,7 +14439,7 @@
                     <a:bodyPr/>
                     <a:lstStyle/>
                     <a:p>
-                      <a:pPr algn="r" indent="0" marL="0">
+                      <a:pPr rtl="1" algn="r" indent="0" marL="0">
                         <a:buNone/>
                       </a:pPr>
                       <a:r>
@@ -14507,7 +14507,7 @@
                     <a:bodyPr/>
                     <a:lstStyle/>
                     <a:p>
-                      <a:pPr algn="r" indent="0" marL="0">
+                      <a:pPr rtl="1" algn="r" indent="0" marL="0">
                         <a:buNone/>
                       </a:pPr>
                       <a:r>
@@ -14630,7 +14630,7 @@
           <a:bodyPr wrap="square" lIns="0" tIns="0" rIns="0" bIns="0" rtlCol="0" anchor="ctr"/>
           <a:lstStyle/>
           <a:p>
-            <a:pPr algn="r" indent="0" marL="0">
+            <a:pPr rtl="1" algn="r" indent="0" marL="0">
               <a:buNone/>
             </a:pPr>
             <a:r>
@@ -14669,7 +14669,7 @@
           <a:bodyPr wrap="square" lIns="0" tIns="0" rIns="0" bIns="0" rtlCol="0" anchor="t"/>
           <a:lstStyle/>
           <a:p>
-            <a:pPr algn="r" indent="0" marL="0">
+            <a:pPr rtl="1" algn="r" indent="0" marL="0">
               <a:buNone/>
             </a:pPr>
             <a:r>
@@ -14742,7 +14742,7 @@
           <a:bodyPr wrap="square" lIns="0" tIns="0" rIns="0" bIns="0" rtlCol="0" anchor="ctr"/>
           <a:lstStyle/>
           <a:p>
-            <a:pPr algn="r" indent="0" marL="0">
+            <a:pPr rtl="1" algn="r" indent="0" marL="0">
               <a:buNone/>
             </a:pPr>
             <a:r>
@@ -14781,7 +14781,7 @@
           <a:bodyPr wrap="square" lIns="0" tIns="0" rIns="0" bIns="0" rtlCol="0" anchor="t"/>
           <a:lstStyle/>
           <a:p>
-            <a:pPr algn="r" indent="0" marL="0">
+            <a:pPr rtl="1" algn="r" indent="0" marL="0">
               <a:buNone/>
             </a:pPr>
             <a:r>
@@ -14854,7 +14854,7 @@
           <a:bodyPr wrap="square" lIns="0" tIns="0" rIns="0" bIns="0" rtlCol="0" anchor="ctr"/>
           <a:lstStyle/>
           <a:p>
-            <a:pPr algn="r" indent="0" marL="0">
+            <a:pPr rtl="1" algn="r" indent="0" marL="0">
               <a:buNone/>
             </a:pPr>
             <a:r>
@@ -14893,7 +14893,7 @@
           <a:bodyPr wrap="square" lIns="0" tIns="0" rIns="0" bIns="0" rtlCol="0" anchor="t"/>
           <a:lstStyle/>
           <a:p>
-            <a:pPr algn="r" indent="0" marL="0">
+            <a:pPr rtl="1" algn="r" indent="0" marL="0">
               <a:buNone/>
             </a:pPr>
             <a:r>
@@ -14932,7 +14932,7 @@
           <a:bodyPr wrap="square" rtlCol="0" anchor="t"/>
           <a:lstStyle/>
           <a:p>
-            <a:pPr algn="r" indent="0" marL="0">
+            <a:pPr rtl="1" algn="r" indent="0" marL="0">
               <a:buNone/>
             </a:pPr>
             <a:r>
@@ -14946,7 +14946,7 @@
               </a:rPr>
               <a:t>מקור הידע (RAG) </a:t>
             </a:r>
-            <a:pPr algn="r" indent="0" marL="0">
+            <a:pPr rtl="1" algn="r" indent="0" marL="0">
               <a:buNone/>
             </a:pPr>
             <a:r>
@@ -14985,7 +14985,7 @@
           <a:bodyPr wrap="square" rtlCol="0" anchor="ctr"/>
           <a:lstStyle/>
           <a:p>
-            <a:pPr algn="l" indent="0" marL="0">
+            <a:pPr rtl="1" algn="l" indent="0" marL="0">
               <a:buNone/>
             </a:pPr>
             <a:r>

</xml_diff>

<commit_message>
Update the submission deck to the current state
20 tables and migrations 002-020, role-based access on the schema slide,
schema.sql described as the base, a new "sharing and trust" slide (trip
roles, kosher trust tiers, 78 RLS checks, try-it demo), date 05/10/2026.

Co-Authored-By: Claude Opus 5.5 <noreply@anthropic.com>
</commit_message>
<xml_diff>
--- a/docs/presentation.pptx
+++ b/docs/presentation.pptx
@@ -19,6 +19,7 @@
     <p:sldId id="267" r:id="rId13"/>
     <p:sldId id="268" r:id="rId14"/>
     <p:sldId id="269" r:id="rId15"/>
+    <p:sldId id="272" r:id="rId23"/>
     <p:sldId id="270" r:id="rId16"/>
     <p:sldId id="271" r:id="rId17"/>
   </p:sldIdLst>
@@ -2437,7 +2438,7 @@
                 <a:ea typeface="Calibri" pitchFamily="34" charset="-122"/>
                 <a:cs typeface="Calibri" pitchFamily="34" charset="-120"/>
               </a:rPr>
-              <a:t>14/09/2026</a:t>
+              <a:t>05/10/2026</a:t>
             </a:r>
             <a:endParaRPr lang="en-US" sz="1250" dirty="0"/>
           </a:p>
@@ -4668,7 +4669,7 @@
                 <a:ea typeface="Calibri" pitchFamily="34" charset="-122"/>
                 <a:cs typeface="Calibri" pitchFamily="34" charset="-120"/>
               </a:rPr>
-              <a:t>רשימת הטיולים, לפי בעלים</a:t>
+              <a:t>הטיולים שלך, ואלה שהוזמנת אליהם</a:t>
             </a:r>
             <a:endParaRPr lang="en-US" sz="1200" dirty="0"/>
           </a:p>
@@ -6784,7 +6785,7 @@
                 <a:ea typeface="Calibri" pitchFamily="34" charset="-122"/>
                 <a:cs typeface="Calibri" pitchFamily="34" charset="-120"/>
               </a:rPr>
-              <a:t>pgvector, 3 יעדים</a:t>
+              <a:t>3 יעדים מאומתים + חיפוש עולמי</a:t>
             </a:r>
             <a:endParaRPr lang="en-US" sz="950" dirty="0"/>
           </a:p>
@@ -7427,7 +7428,7 @@
                 <a:ea typeface="Calibri" pitchFamily="34" charset="-122"/>
                 <a:cs typeface="Calibri" pitchFamily="34" charset="-120"/>
               </a:rPr>
-              <a:t>TripCraft · 15</a:t>
+              <a:t>TripCraft · 16</a:t>
             </a:r>
             <a:endParaRPr lang="en-US" sz="900" dirty="0"/>
           </a:p>
@@ -7865,6 +7866,777 @@
 </p:sld>
 </file>
 
+<file path=ppt/slides/slide17.xml><?xml version="1.0" encoding="utf-8"?>
+<p:sld xmlns:a="http://schemas.openxmlformats.org/drawingml/2006/main" xmlns:r="http://schemas.openxmlformats.org/officeDocument/2006/relationships" xmlns:p="http://schemas.openxmlformats.org/presentationml/2006/main">
+  <p:cSld name="Slide 2">
+    <p:bg>
+      <p:bgPr>
+        <a:solidFill>
+          <a:srgbClr val="F6FBFA"/>
+        </a:solidFill>
+      </p:bgPr>
+    </p:bg>
+    <p:spTree>
+      <p:nvGrpSpPr>
+        <p:cNvPr id="1" name=""/>
+        <p:cNvGrpSpPr/>
+        <p:nvPr/>
+      </p:nvGrpSpPr>
+      <p:grpSpPr>
+        <a:xfrm>
+          <a:off x="0" y="0"/>
+          <a:ext cx="0" cy="0"/>
+          <a:chOff x="0" y="0"/>
+          <a:chExt cx="0" cy="0"/>
+        </a:xfrm>
+      </p:grpSpPr>
+      <p:sp>
+        <p:nvSpPr>
+          <p:cNvPr id="2" name="Text 0"/>
+          <p:cNvSpPr txBox="1"/>
+          <p:nvPr/>
+        </p:nvSpPr>
+        <p:spPr>
+          <a:xfrm>
+            <a:off x="640080" y="384048"/>
+            <a:ext cx="10911535" cy="292608"/>
+          </a:xfrm>
+          <a:prstGeom prst="rect">
+            <a:avLst/>
+          </a:prstGeom>
+          <a:noFill/>
+          <a:ln/>
+        </p:spPr>
+        <p:txBody>
+          <a:bodyPr wrap="square" rtlCol="0" anchor="ctr"/>
+          <a:lstStyle/>
+          <a:p>
+            <a:pPr rtl="1" algn="r" indent="0" marL="0">
+              <a:buNone/>
+            </a:pPr>
+            <a:r>
+              <a:rPr lang="en-US" sz="1200" b="1" spc="200" kern="0" dirty="0">
+                <a:solidFill>
+                  <a:srgbClr val="0E9C96"/>
+                </a:solidFill>
+                <a:latin typeface="Calibri" pitchFamily="34" charset="0"/>
+                <a:ea typeface="Calibri" pitchFamily="34" charset="-122"/>
+                <a:cs typeface="Calibri" pitchFamily="34" charset="-120"/>
+              </a:rPr>
+              <a:t>שיתוף ואמון</a:t>
+            </a:r>
+            <a:endParaRPr lang="en-US" sz="1200" dirty="0"/>
+          </a:p>
+        </p:txBody>
+      </p:sp>
+      <p:sp>
+        <p:nvSpPr>
+          <p:cNvPr id="3" name="Text 1"/>
+          <p:cNvSpPr txBox="1"/>
+          <p:nvPr/>
+        </p:nvSpPr>
+        <p:spPr>
+          <a:xfrm>
+            <a:off x="640080" y="676656"/>
+            <a:ext cx="10911535" cy="822960"/>
+          </a:xfrm>
+          <a:prstGeom prst="rect">
+            <a:avLst/>
+          </a:prstGeom>
+          <a:noFill/>
+          <a:ln/>
+        </p:spPr>
+        <p:txBody>
+          <a:bodyPr wrap="square" rtlCol="0" anchor="t"/>
+          <a:lstStyle/>
+          <a:p>
+            <a:pPr rtl="1" algn="r" indent="0" marL="0">
+              <a:buNone/>
+            </a:pPr>
+            <a:r>
+              <a:rPr lang="en-US" sz="3000" b="1" dirty="0">
+                <a:solidFill>
+                  <a:srgbClr val="0F2E2C"/>
+                </a:solidFill>
+                <a:latin typeface="Calibri" pitchFamily="34" charset="0"/>
+                <a:ea typeface="Calibri" pitchFamily="34" charset="-122"/>
+                <a:cs typeface="Calibri" pitchFamily="34" charset="-120"/>
+              </a:rPr>
+              <a:t>משפחה שלמה בטיול אחד, ומידע שאפשר לסמוך עליו</a:t>
+            </a:r>
+            <a:endParaRPr lang="en-US" sz="3000" dirty="0"/>
+          </a:p>
+        </p:txBody>
+      </p:sp>
+      <p:sp>
+        <p:nvSpPr>
+          <p:cNvPr id="4" name="Text 2"/>
+          <p:cNvSpPr txBox="1"/>
+          <p:nvPr/>
+        </p:nvSpPr>
+        <p:spPr>
+          <a:xfrm>
+            <a:off x="640080" y="1426464"/>
+            <a:ext cx="10911535" cy="502920"/>
+          </a:xfrm>
+          <a:prstGeom prst="rect">
+            <a:avLst/>
+          </a:prstGeom>
+          <a:noFill/>
+          <a:ln/>
+        </p:spPr>
+        <p:txBody>
+          <a:bodyPr wrap="square" rtlCol="0" anchor="t"/>
+          <a:lstStyle/>
+          <a:p>
+            <a:pPr rtl="1" algn="r" indent="0" marL="0">
+              <a:buNone/>
+            </a:pPr>
+            <a:r>
+              <a:rPr lang="en-US" sz="1350" dirty="0">
+                <a:solidFill>
+                  <a:srgbClr val="4B6663"/>
+                </a:solidFill>
+                <a:latin typeface="Calibri" pitchFamily="34" charset="0"/>
+                <a:ea typeface="Calibri" pitchFamily="34" charset="-122"/>
+                <a:cs typeface="Calibri" pitchFamily="34" charset="-120"/>
+              </a:rPr>
+              <a:t>כל בן משפחה רואה ועורך לפי התפקיד שלו, והסוכן אומר במפורש עד כמה אפשר לסמוך על מידע על כשרות.</a:t>
+            </a:r>
+            <a:endParaRPr lang="en-US" sz="1350" dirty="0"/>
+          </a:p>
+        </p:txBody>
+      </p:sp>
+      <p:sp>
+        <p:nvSpPr>
+          <p:cNvPr id="5" name="Shape 3"/>
+          <p:cNvSpPr/>
+          <p:nvPr/>
+        </p:nvSpPr>
+        <p:spPr>
+          <a:xfrm>
+            <a:off x="640080" y="365760"/>
+            <a:ext cx="10911535" cy="0"/>
+          </a:xfrm>
+          <a:prstGeom prst="line">
+            <a:avLst/>
+          </a:prstGeom>
+          <a:noFill/>
+          <a:ln w="9525">
+            <a:solidFill>
+              <a:srgbClr val="D7E9E6"/>
+            </a:solidFill>
+            <a:prstDash val="solid"/>
+          </a:ln>
+        </p:spPr>
+      </p:sp>
+      <p:sp>
+        <p:nvSpPr>
+          <p:cNvPr id="6" name="Shape 4"/>
+          <p:cNvSpPr/>
+          <p:nvPr/>
+        </p:nvSpPr>
+        <p:spPr>
+          <a:xfrm>
+            <a:off x="8104327" y="2148840"/>
+            <a:ext cx="3447288" cy="1371600"/>
+          </a:xfrm>
+          <a:prstGeom prst="roundRect">
+            <a:avLst>
+              <a:gd name="adj" fmla="val 8000"/>
+            </a:avLst>
+          </a:prstGeom>
+          <a:solidFill>
+            <a:srgbClr val="FFFFFF"/>
+          </a:solidFill>
+          <a:ln w="12700">
+            <a:solidFill>
+              <a:srgbClr val="D7E9E6"/>
+            </a:solidFill>
+            <a:prstDash val="solid"/>
+          </a:ln>
+          <a:effectLst>
+            <a:outerShdw sx="100000" sy="100000" kx="0" ky="0" algn="bl" rotWithShape="0" blurRad="127000" dist="38100" dir="5400000">
+              <a:srgbClr val="5B7A76">
+                <a:alpha val="18000"/>
+              </a:srgbClr>
+            </a:outerShdw>
+          </a:effectLst>
+        </p:spPr>
+      </p:sp>
+      <p:sp>
+        <p:nvSpPr>
+          <p:cNvPr id="7" name="Text 5"/>
+          <p:cNvSpPr txBox="1"/>
+          <p:nvPr/>
+        </p:nvSpPr>
+        <p:spPr>
+          <a:xfrm>
+            <a:off x="8241487" y="2276856"/>
+            <a:ext cx="3172968" cy="502920"/>
+          </a:xfrm>
+          <a:prstGeom prst="rect">
+            <a:avLst/>
+          </a:prstGeom>
+          <a:noFill/>
+          <a:ln/>
+        </p:spPr>
+        <p:txBody>
+          <a:bodyPr wrap="square" lIns="0" tIns="0" rIns="0" bIns="0" rtlCol="0" anchor="ctr"/>
+          <a:lstStyle/>
+          <a:p>
+            <a:pPr rtl="1" algn="r" indent="0" marL="0">
+              <a:buNone/>
+            </a:pPr>
+            <a:r>
+              <a:rPr lang="en-US" sz="2600" b="1" dirty="0">
+                <a:solidFill>
+                  <a:srgbClr val="0E9C96"/>
+                </a:solidFill>
+                <a:latin typeface="Calibri" pitchFamily="34" charset="0"/>
+                <a:ea typeface="Calibri" pitchFamily="34" charset="-122"/>
+                <a:cs typeface="Calibri" pitchFamily="34" charset="-120"/>
+              </a:rPr>
+              <a:t>3</a:t>
+            </a:r>
+            <a:endParaRPr lang="en-US" sz="2600" dirty="0"/>
+          </a:p>
+        </p:txBody>
+      </p:sp>
+      <p:sp>
+        <p:nvSpPr>
+          <p:cNvPr id="8" name="Text 6"/>
+          <p:cNvSpPr txBox="1"/>
+          <p:nvPr/>
+        </p:nvSpPr>
+        <p:spPr>
+          <a:xfrm>
+            <a:off x="8241487" y="2807208"/>
+            <a:ext cx="3172968" cy="594360"/>
+          </a:xfrm>
+          <a:prstGeom prst="rect">
+            <a:avLst/>
+          </a:prstGeom>
+          <a:noFill/>
+          <a:ln/>
+        </p:spPr>
+        <p:txBody>
+          <a:bodyPr wrap="square" lIns="0" tIns="0" rIns="0" bIns="0" rtlCol="0" anchor="t"/>
+          <a:lstStyle/>
+          <a:p>
+            <a:pPr rtl="1" algn="r" indent="0" marL="0">
+              <a:buNone/>
+            </a:pPr>
+            <a:r>
+              <a:rPr lang="en-US" sz="1050" dirty="0">
+                <a:solidFill>
+                  <a:srgbClr val="4B6663"/>
+                </a:solidFill>
+                <a:latin typeface="Calibri" pitchFamily="34" charset="0"/>
+                <a:ea typeface="Calibri" pitchFamily="34" charset="-122"/>
+                <a:cs typeface="Calibri" pitchFamily="34" charset="-120"/>
+              </a:rPr>
+              <a:t>תפקידים לחברי טיול: צופה, משתתף ועורך. קישור הזמנה לכל תפקיד, והבעלים מאשר כל מצטרף</a:t>
+            </a:r>
+            <a:endParaRPr lang="en-US" sz="1050" dirty="0"/>
+          </a:p>
+        </p:txBody>
+      </p:sp>
+      <p:sp>
+        <p:nvSpPr>
+          <p:cNvPr id="9" name="Shape 7"/>
+          <p:cNvSpPr/>
+          <p:nvPr/>
+        </p:nvSpPr>
+        <p:spPr>
+          <a:xfrm>
+            <a:off x="4437583" y="2148840"/>
+            <a:ext cx="3447288" cy="1371600"/>
+          </a:xfrm>
+          <a:prstGeom prst="roundRect">
+            <a:avLst>
+              <a:gd name="adj" fmla="val 8000"/>
+            </a:avLst>
+          </a:prstGeom>
+          <a:solidFill>
+            <a:srgbClr val="FFFFFF"/>
+          </a:solidFill>
+          <a:ln w="12700">
+            <a:solidFill>
+              <a:srgbClr val="D7E9E6"/>
+            </a:solidFill>
+            <a:prstDash val="solid"/>
+          </a:ln>
+          <a:effectLst>
+            <a:outerShdw sx="100000" sy="100000" kx="0" ky="0" algn="bl" rotWithShape="0" blurRad="127000" dist="38100" dir="5400000">
+              <a:srgbClr val="5B7A76">
+                <a:alpha val="18000"/>
+              </a:srgbClr>
+            </a:outerShdw>
+          </a:effectLst>
+        </p:spPr>
+      </p:sp>
+      <p:sp>
+        <p:nvSpPr>
+          <p:cNvPr id="10" name="Text 8"/>
+          <p:cNvSpPr txBox="1"/>
+          <p:nvPr/>
+        </p:nvSpPr>
+        <p:spPr>
+          <a:xfrm>
+            <a:off x="4574743" y="2276856"/>
+            <a:ext cx="3172968" cy="502920"/>
+          </a:xfrm>
+          <a:prstGeom prst="rect">
+            <a:avLst/>
+          </a:prstGeom>
+          <a:noFill/>
+          <a:ln/>
+        </p:spPr>
+        <p:txBody>
+          <a:bodyPr wrap="square" lIns="0" tIns="0" rIns="0" bIns="0" rtlCol="0" anchor="ctr"/>
+          <a:lstStyle/>
+          <a:p>
+            <a:pPr rtl="1" algn="r" indent="0" marL="0">
+              <a:buNone/>
+            </a:pPr>
+            <a:r>
+              <a:rPr lang="en-US" sz="2600" b="1" dirty="0">
+                <a:solidFill>
+                  <a:srgbClr val="0E9C96"/>
+                </a:solidFill>
+                <a:latin typeface="Calibri" pitchFamily="34" charset="0"/>
+                <a:ea typeface="Calibri" pitchFamily="34" charset="-122"/>
+                <a:cs typeface="Calibri" pitchFamily="34" charset="-120"/>
+              </a:rPr>
+              <a:t>3</a:t>
+            </a:r>
+            <a:endParaRPr lang="en-US" sz="2600" dirty="0"/>
+          </a:p>
+        </p:txBody>
+      </p:sp>
+      <p:sp>
+        <p:nvSpPr>
+          <p:cNvPr id="11" name="Text 9"/>
+          <p:cNvSpPr txBox="1"/>
+          <p:nvPr/>
+        </p:nvSpPr>
+        <p:spPr>
+          <a:xfrm>
+            <a:off x="4574743" y="2807208"/>
+            <a:ext cx="3172968" cy="594360"/>
+          </a:xfrm>
+          <a:prstGeom prst="rect">
+            <a:avLst/>
+          </a:prstGeom>
+          <a:noFill/>
+          <a:ln/>
+        </p:spPr>
+        <p:txBody>
+          <a:bodyPr wrap="square" lIns="0" tIns="0" rIns="0" bIns="0" rtlCol="0" anchor="t"/>
+          <a:lstStyle/>
+          <a:p>
+            <a:pPr rtl="1" algn="r" indent="0" marL="0">
+              <a:buNone/>
+            </a:pPr>
+            <a:r>
+              <a:rPr lang="en-US" sz="1050" dirty="0">
+                <a:solidFill>
+                  <a:srgbClr val="4B6663"/>
+                </a:solidFill>
+                <a:latin typeface="Calibri" pitchFamily="34" charset="0"/>
+                <a:ea typeface="Calibri" pitchFamily="34" charset="-122"/>
+                <a:cs typeface="Calibri" pitchFamily="34" charset="-120"/>
+              </a:rPr>
+              <a:t>רמות אמון לכשרות: מאומת ממקור ידע עם תאריך, נמצא במפה (לא מוצג ככשר), או אין מידע</a:t>
+            </a:r>
+            <a:endParaRPr lang="en-US" sz="1050" dirty="0"/>
+          </a:p>
+        </p:txBody>
+      </p:sp>
+      <p:sp>
+        <p:nvSpPr>
+          <p:cNvPr id="12" name="Shape 10"/>
+          <p:cNvSpPr/>
+          <p:nvPr/>
+        </p:nvSpPr>
+        <p:spPr>
+          <a:xfrm>
+            <a:off x="770839" y="2148840"/>
+            <a:ext cx="3447288" cy="1371600"/>
+          </a:xfrm>
+          <a:prstGeom prst="roundRect">
+            <a:avLst>
+              <a:gd name="adj" fmla="val 8000"/>
+            </a:avLst>
+          </a:prstGeom>
+          <a:solidFill>
+            <a:srgbClr val="FFFFFF"/>
+          </a:solidFill>
+          <a:ln w="12700">
+            <a:solidFill>
+              <a:srgbClr val="D7E9E6"/>
+            </a:solidFill>
+            <a:prstDash val="solid"/>
+          </a:ln>
+          <a:effectLst>
+            <a:outerShdw sx="100000" sy="100000" kx="0" ky="0" algn="bl" rotWithShape="0" blurRad="127000" dist="38100" dir="5400000">
+              <a:srgbClr val="5B7A76">
+                <a:alpha val="18000"/>
+              </a:srgbClr>
+            </a:outerShdw>
+          </a:effectLst>
+        </p:spPr>
+      </p:sp>
+      <p:sp>
+        <p:nvSpPr>
+          <p:cNvPr id="13" name="Text 11"/>
+          <p:cNvSpPr txBox="1"/>
+          <p:nvPr/>
+        </p:nvSpPr>
+        <p:spPr>
+          <a:xfrm>
+            <a:off x="907999" y="2276856"/>
+            <a:ext cx="3172968" cy="502920"/>
+          </a:xfrm>
+          <a:prstGeom prst="rect">
+            <a:avLst/>
+          </a:prstGeom>
+          <a:noFill/>
+          <a:ln/>
+        </p:spPr>
+        <p:txBody>
+          <a:bodyPr wrap="square" lIns="0" tIns="0" rIns="0" bIns="0" rtlCol="0" anchor="ctr"/>
+          <a:lstStyle/>
+          <a:p>
+            <a:pPr rtl="1" algn="r" indent="0" marL="0">
+              <a:buNone/>
+            </a:pPr>
+            <a:r>
+              <a:rPr lang="en-US" sz="2600" b="1" dirty="0">
+                <a:solidFill>
+                  <a:srgbClr val="0E9C96"/>
+                </a:solidFill>
+                <a:latin typeface="Calibri" pitchFamily="34" charset="0"/>
+                <a:ea typeface="Calibri" pitchFamily="34" charset="-122"/>
+                <a:cs typeface="Calibri" pitchFamily="34" charset="-120"/>
+              </a:rPr>
+              <a:t>78</a:t>
+            </a:r>
+            <a:endParaRPr lang="en-US" sz="2600" dirty="0"/>
+          </a:p>
+        </p:txBody>
+      </p:sp>
+      <p:sp>
+        <p:nvSpPr>
+          <p:cNvPr id="14" name="Text 12"/>
+          <p:cNvSpPr txBox="1"/>
+          <p:nvPr/>
+        </p:nvSpPr>
+        <p:spPr>
+          <a:xfrm>
+            <a:off x="907999" y="2807208"/>
+            <a:ext cx="3172968" cy="594360"/>
+          </a:xfrm>
+          <a:prstGeom prst="rect">
+            <a:avLst/>
+          </a:prstGeom>
+          <a:noFill/>
+          <a:ln/>
+        </p:spPr>
+        <p:txBody>
+          <a:bodyPr wrap="square" lIns="0" tIns="0" rIns="0" bIns="0" rtlCol="0" anchor="t"/>
+          <a:lstStyle/>
+          <a:p>
+            <a:pPr rtl="1" algn="r" indent="0" marL="0">
+              <a:buNone/>
+            </a:pPr>
+            <a:r>
+              <a:rPr lang="en-US" sz="1050" dirty="0">
+                <a:solidFill>
+                  <a:srgbClr val="4B6663"/>
+                </a:solidFill>
+                <a:latin typeface="Calibri" pitchFamily="34" charset="0"/>
+                <a:ea typeface="Calibri" pitchFamily="34" charset="-122"/>
+                <a:cs typeface="Calibri" pitchFamily="34" charset="-120"/>
+              </a:rPr>
+              <a:t>בדיקות הרשאות אוטומטיות מול מסד אמיתי: מה כל תפקיד, זר ומבקר אנונימי יכולים לראות</a:t>
+            </a:r>
+            <a:endParaRPr lang="en-US" sz="1050" dirty="0"/>
+          </a:p>
+        </p:txBody>
+      </p:sp>
+      <p:sp>
+        <p:nvSpPr>
+          <p:cNvPr id="15" name="Shape 13"/>
+          <p:cNvSpPr/>
+          <p:nvPr/>
+        </p:nvSpPr>
+        <p:spPr>
+          <a:xfrm>
+            <a:off x="6248095" y="3794760"/>
+            <a:ext cx="5303520" cy="2148840"/>
+          </a:xfrm>
+          <a:prstGeom prst="roundRect">
+            <a:avLst>
+              <a:gd name="adj" fmla="val 5106"/>
+            </a:avLst>
+          </a:prstGeom>
+          <a:solidFill>
+            <a:srgbClr val="D7F2EF"/>
+          </a:solidFill>
+          <a:ln w="12700">
+            <a:solidFill>
+              <a:srgbClr val="0E9C96"/>
+            </a:solidFill>
+            <a:prstDash val="solid"/>
+          </a:ln>
+          <a:effectLst>
+            <a:outerShdw sx="100000" sy="100000" kx="0" ky="0" algn="bl" rotWithShape="0" blurRad="127000" dist="38100" dir="5400000">
+              <a:srgbClr val="5B7A76">
+                <a:alpha val="18000"/>
+              </a:srgbClr>
+            </a:outerShdw>
+          </a:effectLst>
+        </p:spPr>
+      </p:sp>
+      <p:sp>
+        <p:nvSpPr>
+          <p:cNvPr id="16" name="Text 14"/>
+          <p:cNvSpPr txBox="1"/>
+          <p:nvPr/>
+        </p:nvSpPr>
+        <p:spPr>
+          <a:xfrm>
+            <a:off x="6476695" y="3977640"/>
+            <a:ext cx="4846320" cy="365760"/>
+          </a:xfrm>
+          <a:prstGeom prst="rect">
+            <a:avLst/>
+          </a:prstGeom>
+          <a:noFill/>
+          <a:ln/>
+        </p:spPr>
+        <p:txBody>
+          <a:bodyPr wrap="square" lIns="0" tIns="0" rIns="0" bIns="0" rtlCol="0" anchor="ctr"/>
+          <a:lstStyle/>
+          <a:p>
+            <a:pPr rtl="1" algn="r" indent="0" marL="0">
+              <a:buNone/>
+            </a:pPr>
+            <a:r>
+              <a:rPr lang="en-US" sz="1500" b="1" dirty="0">
+                <a:solidFill>
+                  <a:srgbClr val="0B7671"/>
+                </a:solidFill>
+                <a:latin typeface="Calibri" pitchFamily="34" charset="0"/>
+                <a:ea typeface="Calibri" pitchFamily="34" charset="-122"/>
+                <a:cs typeface="Calibri" pitchFamily="34" charset="-120"/>
+              </a:rPr>
+              <a:t>🍽️ כשרות ושבת בכל יעד</a:t>
+            </a:r>
+            <a:endParaRPr lang="en-US" sz="1500" dirty="0"/>
+          </a:p>
+        </p:txBody>
+      </p:sp>
+      <p:sp>
+        <p:nvSpPr>
+          <p:cNvPr id="17" name="Text 15"/>
+          <p:cNvSpPr txBox="1"/>
+          <p:nvPr/>
+        </p:nvSpPr>
+        <p:spPr>
+          <a:xfrm>
+            <a:off x="6476695" y="4434840"/>
+            <a:ext cx="4846320" cy="1325880"/>
+          </a:xfrm>
+          <a:prstGeom prst="rect">
+            <a:avLst/>
+          </a:prstGeom>
+          <a:noFill/>
+          <a:ln/>
+        </p:spPr>
+        <p:txBody>
+          <a:bodyPr wrap="square" lIns="0" tIns="0" rIns="0" bIns="0" rtlCol="0" anchor="t"/>
+          <a:lstStyle/>
+          <a:p>
+            <a:pPr rtl="1" algn="r" indent="0" marL="0">
+              <a:buNone/>
+            </a:pPr>
+            <a:r>
+              <a:rPr lang="en-US" sz="1150" dirty="0">
+                <a:solidFill>
+                  <a:srgbClr val="4B6663"/>
+                </a:solidFill>
+                <a:latin typeface="Calibri" pitchFamily="34" charset="0"/>
+                <a:ea typeface="Calibri" pitchFamily="34" charset="-122"/>
+                <a:cs typeface="Calibri" pitchFamily="34" charset="-120"/>
+              </a:rPr>
+              <a:t>אוכל כשר מ-OpenStreetMap ו-Google Places סביב היעד, וזמני שבת וחג מ-Hebcal לתאריכי הטיול. מהשרת יוצאות רק קואורדינטות ותאריכים.</a:t>
+            </a:r>
+            <a:endParaRPr lang="en-US" sz="1150" dirty="0"/>
+          </a:p>
+        </p:txBody>
+      </p:sp>
+      <p:sp>
+        <p:nvSpPr>
+          <p:cNvPr id="18" name="Shape 16"/>
+          <p:cNvSpPr/>
+          <p:nvPr/>
+        </p:nvSpPr>
+        <p:spPr>
+          <a:xfrm>
+            <a:off x="640080" y="3794760"/>
+            <a:ext cx="5303520" cy="2148840"/>
+          </a:xfrm>
+          <a:prstGeom prst="roundRect">
+            <a:avLst>
+              <a:gd name="adj" fmla="val 5106"/>
+            </a:avLst>
+          </a:prstGeom>
+          <a:solidFill>
+            <a:srgbClr val="FCE6DD"/>
+          </a:solidFill>
+          <a:ln w="12700">
+            <a:solidFill>
+              <a:srgbClr val="EE6D4E"/>
+            </a:solidFill>
+            <a:prstDash val="solid"/>
+          </a:ln>
+          <a:effectLst>
+            <a:outerShdw sx="100000" sy="100000" kx="0" ky="0" algn="bl" rotWithShape="0" blurRad="127000" dist="38100" dir="5400000">
+              <a:srgbClr val="5B7A76">
+                <a:alpha val="18000"/>
+              </a:srgbClr>
+            </a:outerShdw>
+          </a:effectLst>
+        </p:spPr>
+      </p:sp>
+      <p:sp>
+        <p:nvSpPr>
+          <p:cNvPr id="19" name="Text 17"/>
+          <p:cNvSpPr txBox="1"/>
+          <p:nvPr/>
+        </p:nvSpPr>
+        <p:spPr>
+          <a:xfrm>
+            <a:off x="868680" y="3977640"/>
+            <a:ext cx="4846320" cy="365760"/>
+          </a:xfrm>
+          <a:prstGeom prst="rect">
+            <a:avLst/>
+          </a:prstGeom>
+          <a:noFill/>
+          <a:ln/>
+        </p:spPr>
+        <p:txBody>
+          <a:bodyPr wrap="square" lIns="0" tIns="0" rIns="0" bIns="0" rtlCol="0" anchor="ctr"/>
+          <a:lstStyle/>
+          <a:p>
+            <a:pPr rtl="1" algn="r" indent="0" marL="0">
+              <a:buNone/>
+            </a:pPr>
+            <a:r>
+              <a:rPr lang="en-US" sz="1500" b="1" dirty="0">
+                <a:solidFill>
+                  <a:srgbClr val="B84A32"/>
+                </a:solidFill>
+                <a:latin typeface="Calibri" pitchFamily="34" charset="0"/>
+                <a:ea typeface="Calibri" pitchFamily="34" charset="-122"/>
+                <a:cs typeface="Calibri" pitchFamily="34" charset="-120"/>
+              </a:rPr>
+              <a:t>👀 נסו בעצמכם</a:t>
+            </a:r>
+            <a:endParaRPr lang="en-US" sz="1500" dirty="0"/>
+          </a:p>
+        </p:txBody>
+      </p:sp>
+      <p:sp>
+        <p:nvSpPr>
+          <p:cNvPr id="20" name="Text 18"/>
+          <p:cNvSpPr txBox="1"/>
+          <p:nvPr/>
+        </p:nvSpPr>
+        <p:spPr>
+          <a:xfrm>
+            <a:off x="868680" y="4434840"/>
+            <a:ext cx="4846320" cy="1325880"/>
+          </a:xfrm>
+          <a:prstGeom prst="rect">
+            <a:avLst/>
+          </a:prstGeom>
+          <a:noFill/>
+          <a:ln/>
+        </p:spPr>
+        <p:txBody>
+          <a:bodyPr wrap="square" lIns="0" tIns="0" rIns="0" bIns="0" rtlCol="0" anchor="t"/>
+          <a:lstStyle/>
+          <a:p>
+            <a:pPr rtl="1" algn="r" indent="0" marL="0">
+              <a:buNone/>
+            </a:pPr>
+            <a:r>
+              <a:rPr lang="en-US" sz="1150" dirty="0">
+                <a:solidFill>
+                  <a:srgbClr val="4B6663"/>
+                </a:solidFill>
+                <a:latin typeface="Calibri" pitchFamily="34" charset="0"/>
+                <a:ea typeface="Calibri" pitchFamily="34" charset="-122"/>
+                <a:cs typeface="Calibri" pitchFamily="34" charset="-120"/>
+              </a:rPr>
+              <a:t>גולש בלי חשבון משכפל טיול הדגמה ומשחק בו, עם תקציב AI קטן. הנתונים נמחקים אוטומטית אחרי 7 ימים.</a:t>
+            </a:r>
+            <a:endParaRPr lang="en-US" sz="1150" dirty="0"/>
+          </a:p>
+        </p:txBody>
+      </p:sp>
+      <p:sp>
+        <p:nvSpPr>
+          <p:cNvPr id="21" name="Text 19"/>
+          <p:cNvSpPr txBox="1"/>
+          <p:nvPr/>
+        </p:nvSpPr>
+        <p:spPr>
+          <a:xfrm>
+            <a:off x="9539935" y="6473952"/>
+            <a:ext cx="2011680" cy="256032"/>
+          </a:xfrm>
+          <a:prstGeom prst="rect">
+            <a:avLst/>
+          </a:prstGeom>
+          <a:noFill/>
+          <a:ln/>
+        </p:spPr>
+        <p:txBody>
+          <a:bodyPr wrap="square" rtlCol="0" anchor="ctr"/>
+          <a:lstStyle/>
+          <a:p>
+            <a:pPr rtl="1" algn="l" indent="0" marL="0">
+              <a:buNone/>
+            </a:pPr>
+            <a:r>
+              <a:rPr lang="en-US" sz="900" dirty="0">
+                <a:solidFill>
+                  <a:srgbClr val="6B8480"/>
+                </a:solidFill>
+                <a:latin typeface="Calibri" pitchFamily="34" charset="0"/>
+                <a:ea typeface="Calibri" pitchFamily="34" charset="-122"/>
+                <a:cs typeface="Calibri" pitchFamily="34" charset="-120"/>
+              </a:rPr>
+              <a:t>TripCraft · 15</a:t>
+            </a:r>
+            <a:endParaRPr lang="en-US" sz="900" dirty="0"/>
+          </a:p>
+        </p:txBody>
+      </p:sp>
+    </p:spTree>
+  </p:cSld>
+  <p:clrMapOvr>
+    <a:masterClrMapping/>
+  </p:clrMapOvr>
+</p:sld>
+</file>
+
 <file path=ppt/slides/slide2.xml><?xml version="1.0" encoding="utf-8"?>
 <p:sld xmlns:a="http://schemas.openxmlformats.org/drawingml/2006/main" xmlns:r="http://schemas.openxmlformats.org/officeDocument/2006/relationships" xmlns:p="http://schemas.openxmlformats.org/presentationml/2006/main">
   <p:cSld name="Slide 2">
@@ -8320,7 +9092,7 @@
                 <a:ea typeface="Calibri" pitchFamily="34" charset="-122"/>
                 <a:cs typeface="Calibri" pitchFamily="34" charset="-120"/>
               </a:rPr>
-              <a:t>13</a:t>
+              <a:t>20</a:t>
             </a:r>
             <a:endParaRPr lang="en-US" sz="2600" dirty="0"/>
           </a:p>
@@ -10613,7 +11385,7 @@
                 <a:ea typeface="Calibri" pitchFamily="34" charset="-122"/>
                 <a:cs typeface="Calibri" pitchFamily="34" charset="-120"/>
               </a:rPr>
-              <a:t>13 טבלאות, כולן עם Row Level Security — כלל הגישה נאכף במסד הנתונים עצמו, לא רק בקוד הלקוח. גישה חוצה-בעלים (הסוכן, דוחות מנהל) עוברת דרך פונקציות SECURITY DEFINER ממוקדות (owns_trip(), has_role()) במקום הרפיית ההרשאות עצמן.</a:t>
+              <a:t>20 טבלאות, כולן עם Row Level Security — כלל הגישה נאכף במסד הנתונים עצמו, לא רק בקוד הלקוח. הרשאות לפי תפקיד בטיול (בעלים, עורך, משתתף, צופה) עוברות דרך פונקציות SECURITY DEFINER ממוקדות (can_view_trip(), can_edit_trip(), has_role()) במקום הרפיית ההרשאות עצמן.</a:t>
             </a:r>
             <a:endParaRPr lang="en-US" sz="1150" dirty="0"/>
           </a:p>
@@ -10700,7 +11472,7 @@
                 <a:ea typeface="Calibri" pitchFamily="34" charset="-122"/>
                 <a:cs typeface="Calibri" pitchFamily="34" charset="-120"/>
               </a:rPr>
-              <a:t>כל שינוי סכמה הוא קובץ SQL ממוספר תחת supabase/migrations/ (9 קבצים) — מתועד, בהיסטוריית git, ומופעל על המסד החי. supabase/schema.sql הוא עותק מלא ואידמפוטנטי לבניית מסד חדש בהרצה אחת.</a:t>
+              <a:t>כל שינוי סכמה הוא קובץ SQL ממוספר תחת supabase/migrations/ (002–020) — מתועד, בהיסטוריית git, ומופעל על המסד החי. supabase/schema.sql הוא סכמת הבסיס, ומסד חדש נבנה ממנה ומכל המיגרציות לפי הסדר.</a:t>
             </a:r>
             <a:endParaRPr lang="en-US" sz="1300" dirty="0"/>
           </a:p>

</xml_diff>